<commit_message>
Keep daily math slides and remove production details
</commit_message>
<xml_diff>
--- a/carpentry/intake-141/PowerPoint/Day-01_2026-10-29_Week-1.pptx
+++ b/carpentry/intake-141/PowerPoint/Day-01_2026-10-29_Week-1.pptx
@@ -548,17 +548,7 @@
           <a:lstStyle/>
           <a:p>
             <a:r>
-              <a:t>Daily deck uses only this date’s math blocks from the current visible Carpentry Schedule and Math Week sheets.</a:t>
-            </a:r>
-          </a:p>
-          <a:p>
-            <a:r>
-              <a:t>'Carpentry Schedule'!E3 | 'Math Week 1'!A19</a:t>
-            </a:r>
-          </a:p>
-          <a:p>
-            <a:r>
-              <a:t>'Carpentry Schedule'!E5 | 'Math Week 1'!A36</a:t>
+              <a:t>Introduce today’s math topics and review the timetable.</a:t>
             </a:r>
           </a:p>
         </p:txBody>
@@ -687,11 +677,6 @@
               <a:t>Materials/check: Notebook; calculator</a:t>
             </a:r>
           </a:p>
-          <a:p>
-            <a:r>
-              <a:t>Source: 'Math Week 1'!A25:F25</a:t>
-            </a:r>
-          </a:p>
           <a:p/>
           <a:p>
             <a:r>
@@ -713,11 +698,6 @@
               <a:t>Materials/check: Identify support needs</a:t>
             </a:r>
           </a:p>
-          <a:p>
-            <a:r>
-              <a:t>Source: 'Math Week 1'!A26:F26</a:t>
-            </a:r>
-          </a:p>
           <a:p/>
           <a:p>
             <a:r>
@@ -739,11 +719,6 @@
               <a:t>Materials/check: Textbook; worked example</a:t>
             </a:r>
           </a:p>
-          <a:p>
-            <a:r>
-              <a:t>Source: 'Math Week 1'!A27:F27</a:t>
-            </a:r>
-          </a:p>
           <a:p/>
           <a:p>
             <a:r>
@@ -765,11 +740,6 @@
               <a:t>Materials/check: Exercise Book; tool above</a:t>
             </a:r>
           </a:p>
-          <a:p>
-            <a:r>
-              <a:t>Source: 'Math Week 1'!A28:F28</a:t>
-            </a:r>
-          </a:p>
           <a:p/>
           <a:p>
             <a:r>
@@ -791,11 +761,6 @@
               <a:t>Materials/check: Paper first; tool second</a:t>
             </a:r>
           </a:p>
-          <a:p>
-            <a:r>
-              <a:t>Source: 'Math Week 1'!A29:F29</a:t>
-            </a:r>
-          </a:p>
           <a:p/>
           <a:p>
             <a:r>
@@ -817,11 +782,6 @@
               <a:t>Materials/check: Teacher answers below</a:t>
             </a:r>
           </a:p>
-          <a:p>
-            <a:r>
-              <a:t>Source: 'Math Week 1'!A30:F30</a:t>
-            </a:r>
-          </a:p>
           <a:p/>
           <a:p>
             <a:r>
@@ -843,11 +803,6 @@
               <a:t>Materials/check: Notebook / error log</a:t>
             </a:r>
           </a:p>
-          <a:p>
-            <a:r>
-              <a:t>Source: 'Math Week 1'!A31:F31</a:t>
-            </a:r>
-          </a:p>
           <a:p/>
           <a:p>
             <a:r>
@@ -868,12 +823,7 @@
           <a:p/>
           <a:p>
             <a:r>
-              <a:t>Sources: 'Math Week 1'!A10:E10; 'Carpentry Schedule'!E3; 'Math Week 1'!A19</a:t>
-            </a:r>
-          </a:p>
-          <a:p>
-            <a:r>
-              <a:t>Navigation/resource slides support these scheduled steps and do not add instructional time.</a:t>
+              <a:t>Keep activities within the allocated phase time.</a:t>
             </a:r>
           </a:p>
           <a:p/>
@@ -938,11 +888,6 @@
               <a:t>Materials/check: Notebook; calculator</a:t>
             </a:r>
           </a:p>
-          <a:p>
-            <a:r>
-              <a:t>Source: 'Math Week 1'!A42:F42</a:t>
-            </a:r>
-          </a:p>
           <a:p/>
           <a:p>
             <a:r>
@@ -964,11 +909,6 @@
               <a:t>Materials/check: Identify support needs</a:t>
             </a:r>
           </a:p>
-          <a:p>
-            <a:r>
-              <a:t>Source: 'Math Week 1'!A43:F43</a:t>
-            </a:r>
-          </a:p>
           <a:p/>
           <a:p>
             <a:r>
@@ -990,11 +930,6 @@
               <a:t>Materials/check: Textbook; worked example</a:t>
             </a:r>
           </a:p>
-          <a:p>
-            <a:r>
-              <a:t>Source: 'Math Week 1'!A44:F44</a:t>
-            </a:r>
-          </a:p>
           <a:p/>
           <a:p>
             <a:r>
@@ -1016,11 +951,6 @@
               <a:t>Materials/check: Exercise Book; tool above</a:t>
             </a:r>
           </a:p>
-          <a:p>
-            <a:r>
-              <a:t>Source: 'Math Week 1'!A45:F45</a:t>
-            </a:r>
-          </a:p>
           <a:p/>
           <a:p>
             <a:r>
@@ -1042,11 +972,6 @@
               <a:t>Materials/check: Paper first; tool second</a:t>
             </a:r>
           </a:p>
-          <a:p>
-            <a:r>
-              <a:t>Source: 'Math Week 1'!A46:F46</a:t>
-            </a:r>
-          </a:p>
           <a:p/>
           <a:p>
             <a:r>
@@ -1068,11 +993,6 @@
               <a:t>Materials/check: Teacher answers below</a:t>
             </a:r>
           </a:p>
-          <a:p>
-            <a:r>
-              <a:t>Source: 'Math Week 1'!A47:F47</a:t>
-            </a:r>
-          </a:p>
           <a:p/>
           <a:p>
             <a:r>
@@ -1094,11 +1014,6 @@
               <a:t>Materials/check: Notebook / error log</a:t>
             </a:r>
           </a:p>
-          <a:p>
-            <a:r>
-              <a:t>Source: 'Math Week 1'!A48:F48</a:t>
-            </a:r>
-          </a:p>
           <a:p/>
           <a:p>
             <a:r>
@@ -1119,12 +1034,7 @@
           <a:p/>
           <a:p>
             <a:r>
-              <a:t>Sources: 'Math Week 1'!A11:E11; 'Carpentry Schedule'!E5; 'Math Week 1'!A36</a:t>
-            </a:r>
-          </a:p>
-          <a:p>
-            <a:r>
-              <a:t>Navigation/resource slides support these scheduled steps and do not add instructional time.</a:t>
+              <a:t>Keep activities within the allocated phase time.</a:t>
             </a:r>
           </a:p>
         </p:txBody>
@@ -1253,11 +1163,6 @@
               <a:t>Materials/check: Notebook; calculator</a:t>
             </a:r>
           </a:p>
-          <a:p>
-            <a:r>
-              <a:t>Source: 'Math Week 1'!A25:F25</a:t>
-            </a:r>
-          </a:p>
           <a:p/>
           <a:p>
             <a:r>
@@ -1279,11 +1184,6 @@
               <a:t>Materials/check: Identify support needs</a:t>
             </a:r>
           </a:p>
-          <a:p>
-            <a:r>
-              <a:t>Source: 'Math Week 1'!A26:F26</a:t>
-            </a:r>
-          </a:p>
           <a:p/>
           <a:p>
             <a:r>
@@ -1305,11 +1205,6 @@
               <a:t>Materials/check: Textbook; worked example</a:t>
             </a:r>
           </a:p>
-          <a:p>
-            <a:r>
-              <a:t>Source: 'Math Week 1'!A27:F27</a:t>
-            </a:r>
-          </a:p>
           <a:p/>
           <a:p>
             <a:r>
@@ -1331,11 +1226,6 @@
               <a:t>Materials/check: Exercise Book; tool above</a:t>
             </a:r>
           </a:p>
-          <a:p>
-            <a:r>
-              <a:t>Source: 'Math Week 1'!A28:F28</a:t>
-            </a:r>
-          </a:p>
           <a:p/>
           <a:p>
             <a:r>
@@ -1357,11 +1247,6 @@
               <a:t>Materials/check: Paper first; tool second</a:t>
             </a:r>
           </a:p>
-          <a:p>
-            <a:r>
-              <a:t>Source: 'Math Week 1'!A29:F29</a:t>
-            </a:r>
-          </a:p>
           <a:p/>
           <a:p>
             <a:r>
@@ -1383,11 +1268,6 @@
               <a:t>Materials/check: Teacher answers below</a:t>
             </a:r>
           </a:p>
-          <a:p>
-            <a:r>
-              <a:t>Source: 'Math Week 1'!A30:F30</a:t>
-            </a:r>
-          </a:p>
           <a:p/>
           <a:p>
             <a:r>
@@ -1409,11 +1289,6 @@
               <a:t>Materials/check: Notebook / error log</a:t>
             </a:r>
           </a:p>
-          <a:p>
-            <a:r>
-              <a:t>Source: 'Math Week 1'!A31:F31</a:t>
-            </a:r>
-          </a:p>
           <a:p/>
           <a:p>
             <a:r>
@@ -1434,17 +1309,12 @@
           <a:p/>
           <a:p>
             <a:r>
-              <a:t>Sources: 'Math Week 1'!A10:E10; 'Carpentry Schedule'!E3; 'Math Week 1'!A19</a:t>
-            </a:r>
-          </a:p>
-          <a:p>
-            <a:r>
-              <a:t>Navigation/resource slides support these scheduled steps and do not add instructional time.</a:t>
-            </a:r>
-          </a:p>
-          <a:p>
-            <a:r>
-              <a:t>SLIDE PLACEMENT: Start, 9:00 AM–9:05 AM. All slides with this phase share these 5 minutes; do not restart the time allocation for each slide.</a:t>
+              <a:t>Keep activities within the allocated phase time.</a:t>
+            </a:r>
+          </a:p>
+          <a:p>
+            <a:r>
+              <a:t>PHASE TIMING: Start, 9:00 AM–9:05 AM. All slides with this phase share these 5 minutes; do not restart the time allocation for each slide.</a:t>
             </a:r>
           </a:p>
         </p:txBody>
@@ -1573,11 +1443,6 @@
               <a:t>Materials/check: Notebook; calculator</a:t>
             </a:r>
           </a:p>
-          <a:p>
-            <a:r>
-              <a:t>Source: 'Math Week 1'!A25:F25</a:t>
-            </a:r>
-          </a:p>
           <a:p/>
           <a:p>
             <a:r>
@@ -1599,11 +1464,6 @@
               <a:t>Materials/check: Identify support needs</a:t>
             </a:r>
           </a:p>
-          <a:p>
-            <a:r>
-              <a:t>Source: 'Math Week 1'!A26:F26</a:t>
-            </a:r>
-          </a:p>
           <a:p/>
           <a:p>
             <a:r>
@@ -1625,11 +1485,6 @@
               <a:t>Materials/check: Textbook; worked example</a:t>
             </a:r>
           </a:p>
-          <a:p>
-            <a:r>
-              <a:t>Source: 'Math Week 1'!A27:F27</a:t>
-            </a:r>
-          </a:p>
           <a:p/>
           <a:p>
             <a:r>
@@ -1651,11 +1506,6 @@
               <a:t>Materials/check: Exercise Book; tool above</a:t>
             </a:r>
           </a:p>
-          <a:p>
-            <a:r>
-              <a:t>Source: 'Math Week 1'!A28:F28</a:t>
-            </a:r>
-          </a:p>
           <a:p/>
           <a:p>
             <a:r>
@@ -1677,11 +1527,6 @@
               <a:t>Materials/check: Paper first; tool second</a:t>
             </a:r>
           </a:p>
-          <a:p>
-            <a:r>
-              <a:t>Source: 'Math Week 1'!A29:F29</a:t>
-            </a:r>
-          </a:p>
           <a:p/>
           <a:p>
             <a:r>
@@ -1703,11 +1548,6 @@
               <a:t>Materials/check: Teacher answers below</a:t>
             </a:r>
           </a:p>
-          <a:p>
-            <a:r>
-              <a:t>Source: 'Math Week 1'!A30:F30</a:t>
-            </a:r>
-          </a:p>
           <a:p/>
           <a:p>
             <a:r>
@@ -1729,11 +1569,6 @@
               <a:t>Materials/check: Notebook / error log</a:t>
             </a:r>
           </a:p>
-          <a:p>
-            <a:r>
-              <a:t>Source: 'Math Week 1'!A31:F31</a:t>
-            </a:r>
-          </a:p>
           <a:p/>
           <a:p>
             <a:r>
@@ -1754,17 +1589,12 @@
           <a:p/>
           <a:p>
             <a:r>
-              <a:t>Sources: 'Math Week 1'!A10:E10; 'Carpentry Schedule'!E3; 'Math Week 1'!A19</a:t>
-            </a:r>
-          </a:p>
-          <a:p>
-            <a:r>
-              <a:t>Navigation/resource slides support these scheduled steps and do not add instructional time.</a:t>
-            </a:r>
-          </a:p>
-          <a:p>
-            <a:r>
-              <a:t>SLIDE PLACEMENT: Recall, 9:05 AM–9:10 AM. All slides with this phase share these 5 minutes; do not restart the time allocation for each slide.</a:t>
+              <a:t>Keep activities within the allocated phase time.</a:t>
+            </a:r>
+          </a:p>
+          <a:p>
+            <a:r>
+              <a:t>PHASE TIMING: Recall, 9:05 AM–9:10 AM. All slides with this phase share these 5 minutes; do not restart the time allocation for each slide.</a:t>
             </a:r>
           </a:p>
         </p:txBody>
@@ -1893,11 +1723,6 @@
               <a:t>Materials/check: Notebook; calculator</a:t>
             </a:r>
           </a:p>
-          <a:p>
-            <a:r>
-              <a:t>Source: 'Math Week 1'!A25:F25</a:t>
-            </a:r>
-          </a:p>
           <a:p/>
           <a:p>
             <a:r>
@@ -1919,11 +1744,6 @@
               <a:t>Materials/check: Identify support needs</a:t>
             </a:r>
           </a:p>
-          <a:p>
-            <a:r>
-              <a:t>Source: 'Math Week 1'!A26:F26</a:t>
-            </a:r>
-          </a:p>
           <a:p/>
           <a:p>
             <a:r>
@@ -1945,11 +1765,6 @@
               <a:t>Materials/check: Textbook; worked example</a:t>
             </a:r>
           </a:p>
-          <a:p>
-            <a:r>
-              <a:t>Source: 'Math Week 1'!A27:F27</a:t>
-            </a:r>
-          </a:p>
           <a:p/>
           <a:p>
             <a:r>
@@ -1971,11 +1786,6 @@
               <a:t>Materials/check: Exercise Book; tool above</a:t>
             </a:r>
           </a:p>
-          <a:p>
-            <a:r>
-              <a:t>Source: 'Math Week 1'!A28:F28</a:t>
-            </a:r>
-          </a:p>
           <a:p/>
           <a:p>
             <a:r>
@@ -1997,11 +1807,6 @@
               <a:t>Materials/check: Paper first; tool second</a:t>
             </a:r>
           </a:p>
-          <a:p>
-            <a:r>
-              <a:t>Source: 'Math Week 1'!A29:F29</a:t>
-            </a:r>
-          </a:p>
           <a:p/>
           <a:p>
             <a:r>
@@ -2023,11 +1828,6 @@
               <a:t>Materials/check: Teacher answers below</a:t>
             </a:r>
           </a:p>
-          <a:p>
-            <a:r>
-              <a:t>Source: 'Math Week 1'!A30:F30</a:t>
-            </a:r>
-          </a:p>
           <a:p/>
           <a:p>
             <a:r>
@@ -2049,11 +1849,6 @@
               <a:t>Materials/check: Notebook / error log</a:t>
             </a:r>
           </a:p>
-          <a:p>
-            <a:r>
-              <a:t>Source: 'Math Week 1'!A31:F31</a:t>
-            </a:r>
-          </a:p>
           <a:p/>
           <a:p>
             <a:r>
@@ -2074,17 +1869,12 @@
           <a:p/>
           <a:p>
             <a:r>
-              <a:t>Sources: 'Math Week 1'!A10:E10; 'Carpentry Schedule'!E3; 'Math Week 1'!A19</a:t>
-            </a:r>
-          </a:p>
-          <a:p>
-            <a:r>
-              <a:t>Navigation/resource slides support these scheduled steps and do not add instructional time.</a:t>
-            </a:r>
-          </a:p>
-          <a:p>
-            <a:r>
-              <a:t>SLIDE PLACEMENT: Recall, 9:05 AM–9:10 AM. All slides with this phase share these 5 minutes; do not restart the time allocation for each slide.</a:t>
+              <a:t>Keep activities within the allocated phase time.</a:t>
+            </a:r>
+          </a:p>
+          <a:p>
+            <a:r>
+              <a:t>PHASE TIMING: Recall, 9:05 AM–9:10 AM. All slides with this phase share these 5 minutes; do not restart the time allocation for each slide.</a:t>
             </a:r>
           </a:p>
           <a:p/>
@@ -2239,11 +2029,6 @@
               <a:t>Materials/check: Notebook; calculator</a:t>
             </a:r>
           </a:p>
-          <a:p>
-            <a:r>
-              <a:t>Source: 'Math Week 1'!A25:F25</a:t>
-            </a:r>
-          </a:p>
           <a:p/>
           <a:p>
             <a:r>
@@ -2265,11 +2050,6 @@
               <a:t>Materials/check: Identify support needs</a:t>
             </a:r>
           </a:p>
-          <a:p>
-            <a:r>
-              <a:t>Source: 'Math Week 1'!A26:F26</a:t>
-            </a:r>
-          </a:p>
           <a:p/>
           <a:p>
             <a:r>
@@ -2291,11 +2071,6 @@
               <a:t>Materials/check: Textbook; worked example</a:t>
             </a:r>
           </a:p>
-          <a:p>
-            <a:r>
-              <a:t>Source: 'Math Week 1'!A27:F27</a:t>
-            </a:r>
-          </a:p>
           <a:p/>
           <a:p>
             <a:r>
@@ -2317,11 +2092,6 @@
               <a:t>Materials/check: Exercise Book; tool above</a:t>
             </a:r>
           </a:p>
-          <a:p>
-            <a:r>
-              <a:t>Source: 'Math Week 1'!A28:F28</a:t>
-            </a:r>
-          </a:p>
           <a:p/>
           <a:p>
             <a:r>
@@ -2343,11 +2113,6 @@
               <a:t>Materials/check: Paper first; tool second</a:t>
             </a:r>
           </a:p>
-          <a:p>
-            <a:r>
-              <a:t>Source: 'Math Week 1'!A29:F29</a:t>
-            </a:r>
-          </a:p>
           <a:p/>
           <a:p>
             <a:r>
@@ -2369,11 +2134,6 @@
               <a:t>Materials/check: Teacher answers below</a:t>
             </a:r>
           </a:p>
-          <a:p>
-            <a:r>
-              <a:t>Source: 'Math Week 1'!A30:F30</a:t>
-            </a:r>
-          </a:p>
           <a:p/>
           <a:p>
             <a:r>
@@ -2395,11 +2155,6 @@
               <a:t>Materials/check: Notebook / error log</a:t>
             </a:r>
           </a:p>
-          <a:p>
-            <a:r>
-              <a:t>Source: 'Math Week 1'!A31:F31</a:t>
-            </a:r>
-          </a:p>
           <a:p/>
           <a:p>
             <a:r>
@@ -2420,48 +2175,23 @@
           <a:p/>
           <a:p>
             <a:r>
-              <a:t>Sources: 'Math Week 1'!A10:E10; 'Carpentry Schedule'!E3; 'Math Week 1'!A19</a:t>
-            </a:r>
-          </a:p>
-          <a:p>
-            <a:r>
-              <a:t>Navigation/resource slides support these scheduled steps and do not add instructional time.</a:t>
-            </a:r>
-          </a:p>
-          <a:p>
-            <a:r>
-              <a:t>SLIDE PLACEMENT: Teach, 9:10 AM–9:25 AM. All slides with this phase share these 15 minutes; do not restart the time allocation for each slide.</a:t>
-            </a:r>
-          </a:p>
-          <a:p/>
-          <a:p>
-            <a:r>
-              <a:t>Teaching content sources:</a:t>
-            </a:r>
-          </a:p>
-          <a:p>
-            <a:r>
-              <a:t>'Math Week 1'!A19</a:t>
-            </a:r>
-          </a:p>
-          <a:p>
-            <a:r>
-              <a:t>'Math Week 1'!B21</a:t>
-            </a:r>
-          </a:p>
-          <a:p>
-            <a:r>
-              <a:t>'Math Week 1'!B23</a:t>
+              <a:t>Keep activities within the allocated phase time.</a:t>
+            </a:r>
+          </a:p>
+          <a:p>
+            <a:r>
+              <a:t>PHASE TIMING: Teach, 9:10 AM–9:25 AM. All slides with this phase share these 15 minutes; do not restart the time allocation for each slide.</a:t>
+            </a:r>
+          </a:p>
+          <a:p/>
+          <a:p>
+            <a:r>
+              <a:t>Teaching references:</a:t>
             </a:r>
           </a:p>
           <a:p>
             <a:r>
               <a:t>Textbook Chapter 1 pp.10–21; Chapter 2 pp.28–31,39</a:t>
-            </a:r>
-          </a:p>
-          <a:p>
-            <a:r>
-              <a:t>ACCESS CARPENTRY SLIDES.pptx slides 3–5</a:t>
             </a:r>
           </a:p>
           <a:p>
@@ -2595,11 +2325,6 @@
               <a:t>Materials/check: Notebook; calculator</a:t>
             </a:r>
           </a:p>
-          <a:p>
-            <a:r>
-              <a:t>Source: 'Math Week 1'!A25:F25</a:t>
-            </a:r>
-          </a:p>
           <a:p/>
           <a:p>
             <a:r>
@@ -2621,11 +2346,6 @@
               <a:t>Materials/check: Identify support needs</a:t>
             </a:r>
           </a:p>
-          <a:p>
-            <a:r>
-              <a:t>Source: 'Math Week 1'!A26:F26</a:t>
-            </a:r>
-          </a:p>
           <a:p/>
           <a:p>
             <a:r>
@@ -2647,11 +2367,6 @@
               <a:t>Materials/check: Textbook; worked example</a:t>
             </a:r>
           </a:p>
-          <a:p>
-            <a:r>
-              <a:t>Source: 'Math Week 1'!A27:F27</a:t>
-            </a:r>
-          </a:p>
           <a:p/>
           <a:p>
             <a:r>
@@ -2673,11 +2388,6 @@
               <a:t>Materials/check: Exercise Book; tool above</a:t>
             </a:r>
           </a:p>
-          <a:p>
-            <a:r>
-              <a:t>Source: 'Math Week 1'!A28:F28</a:t>
-            </a:r>
-          </a:p>
           <a:p/>
           <a:p>
             <a:r>
@@ -2699,11 +2409,6 @@
               <a:t>Materials/check: Paper first; tool second</a:t>
             </a:r>
           </a:p>
-          <a:p>
-            <a:r>
-              <a:t>Source: 'Math Week 1'!A29:F29</a:t>
-            </a:r>
-          </a:p>
           <a:p/>
           <a:p>
             <a:r>
@@ -2725,11 +2430,6 @@
               <a:t>Materials/check: Teacher answers below</a:t>
             </a:r>
           </a:p>
-          <a:p>
-            <a:r>
-              <a:t>Source: 'Math Week 1'!A30:F30</a:t>
-            </a:r>
-          </a:p>
           <a:p/>
           <a:p>
             <a:r>
@@ -2751,11 +2451,6 @@
               <a:t>Materials/check: Notebook / error log</a:t>
             </a:r>
           </a:p>
-          <a:p>
-            <a:r>
-              <a:t>Source: 'Math Week 1'!A31:F31</a:t>
-            </a:r>
-          </a:p>
           <a:p/>
           <a:p>
             <a:r>
@@ -2776,48 +2471,23 @@
           <a:p/>
           <a:p>
             <a:r>
-              <a:t>Sources: 'Math Week 1'!A10:E10; 'Carpentry Schedule'!E3; 'Math Week 1'!A19</a:t>
-            </a:r>
-          </a:p>
-          <a:p>
-            <a:r>
-              <a:t>Navigation/resource slides support these scheduled steps and do not add instructional time.</a:t>
-            </a:r>
-          </a:p>
-          <a:p>
-            <a:r>
-              <a:t>SLIDE PLACEMENT: Teach, 9:10 AM–9:25 AM. All slides with this phase share these 15 minutes; do not restart the time allocation for each slide.</a:t>
-            </a:r>
-          </a:p>
-          <a:p/>
-          <a:p>
-            <a:r>
-              <a:t>Teaching content sources:</a:t>
-            </a:r>
-          </a:p>
-          <a:p>
-            <a:r>
-              <a:t>'Math Week 1'!A19</a:t>
-            </a:r>
-          </a:p>
-          <a:p>
-            <a:r>
-              <a:t>'Math Week 1'!B21</a:t>
-            </a:r>
-          </a:p>
-          <a:p>
-            <a:r>
-              <a:t>'Math Week 1'!B23</a:t>
+              <a:t>Keep activities within the allocated phase time.</a:t>
+            </a:r>
+          </a:p>
+          <a:p>
+            <a:r>
+              <a:t>PHASE TIMING: Teach, 9:10 AM–9:25 AM. All slides with this phase share these 15 minutes; do not restart the time allocation for each slide.</a:t>
+            </a:r>
+          </a:p>
+          <a:p/>
+          <a:p>
+            <a:r>
+              <a:t>Teaching references:</a:t>
             </a:r>
           </a:p>
           <a:p>
             <a:r>
               <a:t>Textbook Chapter 1 pp.10–21; Chapter 2 pp.28–31,39</a:t>
-            </a:r>
-          </a:p>
-          <a:p>
-            <a:r>
-              <a:t>ACCESS CARPENTRY SLIDES.pptx slides 3–5</a:t>
             </a:r>
           </a:p>
           <a:p>
@@ -2951,11 +2621,6 @@
               <a:t>Materials/check: Notebook; calculator</a:t>
             </a:r>
           </a:p>
-          <a:p>
-            <a:r>
-              <a:t>Source: 'Math Week 1'!A25:F25</a:t>
-            </a:r>
-          </a:p>
           <a:p/>
           <a:p>
             <a:r>
@@ -2977,11 +2642,6 @@
               <a:t>Materials/check: Identify support needs</a:t>
             </a:r>
           </a:p>
-          <a:p>
-            <a:r>
-              <a:t>Source: 'Math Week 1'!A26:F26</a:t>
-            </a:r>
-          </a:p>
           <a:p/>
           <a:p>
             <a:r>
@@ -3003,11 +2663,6 @@
               <a:t>Materials/check: Textbook; worked example</a:t>
             </a:r>
           </a:p>
-          <a:p>
-            <a:r>
-              <a:t>Source: 'Math Week 1'!A27:F27</a:t>
-            </a:r>
-          </a:p>
           <a:p/>
           <a:p>
             <a:r>
@@ -3029,11 +2684,6 @@
               <a:t>Materials/check: Exercise Book; tool above</a:t>
             </a:r>
           </a:p>
-          <a:p>
-            <a:r>
-              <a:t>Source: 'Math Week 1'!A28:F28</a:t>
-            </a:r>
-          </a:p>
           <a:p/>
           <a:p>
             <a:r>
@@ -3055,11 +2705,6 @@
               <a:t>Materials/check: Paper first; tool second</a:t>
             </a:r>
           </a:p>
-          <a:p>
-            <a:r>
-              <a:t>Source: 'Math Week 1'!A29:F29</a:t>
-            </a:r>
-          </a:p>
           <a:p/>
           <a:p>
             <a:r>
@@ -3081,11 +2726,6 @@
               <a:t>Materials/check: Teacher answers below</a:t>
             </a:r>
           </a:p>
-          <a:p>
-            <a:r>
-              <a:t>Source: 'Math Week 1'!A30:F30</a:t>
-            </a:r>
-          </a:p>
           <a:p/>
           <a:p>
             <a:r>
@@ -3107,11 +2747,6 @@
               <a:t>Materials/check: Notebook / error log</a:t>
             </a:r>
           </a:p>
-          <a:p>
-            <a:r>
-              <a:t>Source: 'Math Week 1'!A31:F31</a:t>
-            </a:r>
-          </a:p>
           <a:p/>
           <a:p>
             <a:r>
@@ -3132,17 +2767,12 @@
           <a:p/>
           <a:p>
             <a:r>
-              <a:t>Sources: 'Math Week 1'!A10:E10; 'Carpentry Schedule'!E3; 'Math Week 1'!A19</a:t>
-            </a:r>
-          </a:p>
-          <a:p>
-            <a:r>
-              <a:t>Navigation/resource slides support these scheduled steps and do not add instructional time.</a:t>
-            </a:r>
-          </a:p>
-          <a:p>
-            <a:r>
-              <a:t>SLIDE PLACEMENT: Teach, 9:10 AM–9:25 AM. All slides with this phase share these 15 minutes; do not restart the time allocation for each slide.</a:t>
+              <a:t>Keep activities within the allocated phase time.</a:t>
+            </a:r>
+          </a:p>
+          <a:p>
+            <a:r>
+              <a:t>PHASE TIMING: Teach, 9:10 AM–9:25 AM. All slides with this phase share these 15 minutes; do not restart the time allocation for each slide.</a:t>
             </a:r>
           </a:p>
           <a:p/>
@@ -3153,7 +2783,7 @@
           </a:p>
           <a:p>
             <a:r>
-              <a:t>Exact PDF/printed page: 12. Excerpt reproduced from the supplied ACCESS Textbook.</a:t>
+              <a:t>Exact PDF/printed page: 12. ACCESS Textbook excerpt.</a:t>
             </a:r>
           </a:p>
           <a:p>
@@ -3287,11 +2917,6 @@
               <a:t>Materials/check: Notebook; calculator</a:t>
             </a:r>
           </a:p>
-          <a:p>
-            <a:r>
-              <a:t>Source: 'Math Week 1'!A25:F25</a:t>
-            </a:r>
-          </a:p>
           <a:p/>
           <a:p>
             <a:r>
@@ -3313,11 +2938,6 @@
               <a:t>Materials/check: Identify support needs</a:t>
             </a:r>
           </a:p>
-          <a:p>
-            <a:r>
-              <a:t>Source: 'Math Week 1'!A26:F26</a:t>
-            </a:r>
-          </a:p>
           <a:p/>
           <a:p>
             <a:r>
@@ -3339,11 +2959,6 @@
               <a:t>Materials/check: Textbook; worked example</a:t>
             </a:r>
           </a:p>
-          <a:p>
-            <a:r>
-              <a:t>Source: 'Math Week 1'!A27:F27</a:t>
-            </a:r>
-          </a:p>
           <a:p/>
           <a:p>
             <a:r>
@@ -3365,11 +2980,6 @@
               <a:t>Materials/check: Exercise Book; tool above</a:t>
             </a:r>
           </a:p>
-          <a:p>
-            <a:r>
-              <a:t>Source: 'Math Week 1'!A28:F28</a:t>
-            </a:r>
-          </a:p>
           <a:p/>
           <a:p>
             <a:r>
@@ -3391,11 +3001,6 @@
               <a:t>Materials/check: Paper first; tool second</a:t>
             </a:r>
           </a:p>
-          <a:p>
-            <a:r>
-              <a:t>Source: 'Math Week 1'!A29:F29</a:t>
-            </a:r>
-          </a:p>
           <a:p/>
           <a:p>
             <a:r>
@@ -3417,11 +3022,6 @@
               <a:t>Materials/check: Teacher answers below</a:t>
             </a:r>
           </a:p>
-          <a:p>
-            <a:r>
-              <a:t>Source: 'Math Week 1'!A30:F30</a:t>
-            </a:r>
-          </a:p>
           <a:p/>
           <a:p>
             <a:r>
@@ -3443,11 +3043,6 @@
               <a:t>Materials/check: Notebook / error log</a:t>
             </a:r>
           </a:p>
-          <a:p>
-            <a:r>
-              <a:t>Source: 'Math Week 1'!A31:F31</a:t>
-            </a:r>
-          </a:p>
           <a:p/>
           <a:p>
             <a:r>
@@ -3468,17 +3063,12 @@
           <a:p/>
           <a:p>
             <a:r>
-              <a:t>Sources: 'Math Week 1'!A10:E10; 'Carpentry Schedule'!E3; 'Math Week 1'!A19</a:t>
-            </a:r>
-          </a:p>
-          <a:p>
-            <a:r>
-              <a:t>Navigation/resource slides support these scheduled steps and do not add instructional time.</a:t>
-            </a:r>
-          </a:p>
-          <a:p>
-            <a:r>
-              <a:t>SLIDE PLACEMENT: Teach, 9:10 AM–9:25 AM. All slides with this phase share these 15 minutes; do not restart the time allocation for each slide.</a:t>
+              <a:t>Keep activities within the allocated phase time.</a:t>
+            </a:r>
+          </a:p>
+          <a:p>
+            <a:r>
+              <a:t>PHASE TIMING: Teach, 9:10 AM–9:25 AM. All slides with this phase share these 15 minutes; do not restart the time allocation for each slide.</a:t>
             </a:r>
           </a:p>
           <a:p/>
@@ -3489,7 +3079,7 @@
           </a:p>
           <a:p>
             <a:r>
-              <a:t>Exact PDF/printed page: 12. Excerpt reproduced from the supplied ACCESS Textbook.</a:t>
+              <a:t>Exact PDF/printed page: 12. ACCESS Textbook excerpt.</a:t>
             </a:r>
           </a:p>
           <a:p>
@@ -3623,11 +3213,6 @@
               <a:t>Materials/check: Notebook; calculator</a:t>
             </a:r>
           </a:p>
-          <a:p>
-            <a:r>
-              <a:t>Source: 'Math Week 1'!A25:F25</a:t>
-            </a:r>
-          </a:p>
           <a:p/>
           <a:p>
             <a:r>
@@ -3649,11 +3234,6 @@
               <a:t>Materials/check: Identify support needs</a:t>
             </a:r>
           </a:p>
-          <a:p>
-            <a:r>
-              <a:t>Source: 'Math Week 1'!A26:F26</a:t>
-            </a:r>
-          </a:p>
           <a:p/>
           <a:p>
             <a:r>
@@ -3675,11 +3255,6 @@
               <a:t>Materials/check: Textbook; worked example</a:t>
             </a:r>
           </a:p>
-          <a:p>
-            <a:r>
-              <a:t>Source: 'Math Week 1'!A27:F27</a:t>
-            </a:r>
-          </a:p>
           <a:p/>
           <a:p>
             <a:r>
@@ -3701,11 +3276,6 @@
               <a:t>Materials/check: Exercise Book; tool above</a:t>
             </a:r>
           </a:p>
-          <a:p>
-            <a:r>
-              <a:t>Source: 'Math Week 1'!A28:F28</a:t>
-            </a:r>
-          </a:p>
           <a:p/>
           <a:p>
             <a:r>
@@ -3727,11 +3297,6 @@
               <a:t>Materials/check: Paper first; tool second</a:t>
             </a:r>
           </a:p>
-          <a:p>
-            <a:r>
-              <a:t>Source: 'Math Week 1'!A29:F29</a:t>
-            </a:r>
-          </a:p>
           <a:p/>
           <a:p>
             <a:r>
@@ -3753,11 +3318,6 @@
               <a:t>Materials/check: Teacher answers below</a:t>
             </a:r>
           </a:p>
-          <a:p>
-            <a:r>
-              <a:t>Source: 'Math Week 1'!A30:F30</a:t>
-            </a:r>
-          </a:p>
           <a:p/>
           <a:p>
             <a:r>
@@ -3779,11 +3339,6 @@
               <a:t>Materials/check: Notebook / error log</a:t>
             </a:r>
           </a:p>
-          <a:p>
-            <a:r>
-              <a:t>Source: 'Math Week 1'!A31:F31</a:t>
-            </a:r>
-          </a:p>
           <a:p/>
           <a:p>
             <a:r>
@@ -3804,17 +3359,12 @@
           <a:p/>
           <a:p>
             <a:r>
-              <a:t>Sources: 'Math Week 1'!A10:E10; 'Carpentry Schedule'!E3; 'Math Week 1'!A19</a:t>
-            </a:r>
-          </a:p>
-          <a:p>
-            <a:r>
-              <a:t>Navigation/resource slides support these scheduled steps and do not add instructional time.</a:t>
-            </a:r>
-          </a:p>
-          <a:p>
-            <a:r>
-              <a:t>SLIDE PLACEMENT: Teach, 9:10 AM–9:25 AM. All slides with this phase share these 15 minutes; do not restart the time allocation for each slide.</a:t>
+              <a:t>Keep activities within the allocated phase time.</a:t>
+            </a:r>
+          </a:p>
+          <a:p>
+            <a:r>
+              <a:t>PHASE TIMING: Teach, 9:10 AM–9:25 AM. All slides with this phase share these 15 minutes; do not restart the time allocation for each slide.</a:t>
             </a:r>
           </a:p>
           <a:p/>
@@ -3949,11 +3499,6 @@
               <a:t>Materials/check: Notebook; calculator</a:t>
             </a:r>
           </a:p>
-          <a:p>
-            <a:r>
-              <a:t>Source: 'Math Week 1'!A25:F25</a:t>
-            </a:r>
-          </a:p>
           <a:p/>
           <a:p>
             <a:r>
@@ -3975,11 +3520,6 @@
               <a:t>Materials/check: Identify support needs</a:t>
             </a:r>
           </a:p>
-          <a:p>
-            <a:r>
-              <a:t>Source: 'Math Week 1'!A26:F26</a:t>
-            </a:r>
-          </a:p>
           <a:p/>
           <a:p>
             <a:r>
@@ -4001,11 +3541,6 @@
               <a:t>Materials/check: Textbook; worked example</a:t>
             </a:r>
           </a:p>
-          <a:p>
-            <a:r>
-              <a:t>Source: 'Math Week 1'!A27:F27</a:t>
-            </a:r>
-          </a:p>
           <a:p/>
           <a:p>
             <a:r>
@@ -4027,11 +3562,6 @@
               <a:t>Materials/check: Exercise Book; tool above</a:t>
             </a:r>
           </a:p>
-          <a:p>
-            <a:r>
-              <a:t>Source: 'Math Week 1'!A28:F28</a:t>
-            </a:r>
-          </a:p>
           <a:p/>
           <a:p>
             <a:r>
@@ -4053,11 +3583,6 @@
               <a:t>Materials/check: Paper first; tool second</a:t>
             </a:r>
           </a:p>
-          <a:p>
-            <a:r>
-              <a:t>Source: 'Math Week 1'!A29:F29</a:t>
-            </a:r>
-          </a:p>
           <a:p/>
           <a:p>
             <a:r>
@@ -4079,11 +3604,6 @@
               <a:t>Materials/check: Teacher answers below</a:t>
             </a:r>
           </a:p>
-          <a:p>
-            <a:r>
-              <a:t>Source: 'Math Week 1'!A30:F30</a:t>
-            </a:r>
-          </a:p>
           <a:p/>
           <a:p>
             <a:r>
@@ -4105,11 +3625,6 @@
               <a:t>Materials/check: Notebook / error log</a:t>
             </a:r>
           </a:p>
-          <a:p>
-            <a:r>
-              <a:t>Source: 'Math Week 1'!A31:F31</a:t>
-            </a:r>
-          </a:p>
           <a:p/>
           <a:p>
             <a:r>
@@ -4130,17 +3645,12 @@
           <a:p/>
           <a:p>
             <a:r>
-              <a:t>Sources: 'Math Week 1'!A10:E10; 'Carpentry Schedule'!E3; 'Math Week 1'!A19</a:t>
-            </a:r>
-          </a:p>
-          <a:p>
-            <a:r>
-              <a:t>Navigation/resource slides support these scheduled steps and do not add instructional time.</a:t>
-            </a:r>
-          </a:p>
-          <a:p>
-            <a:r>
-              <a:t>SLIDE PLACEMENT: Together, 9:25 AM–9:40 AM. All slides with this phase share these 15 minutes; do not restart the time allocation for each slide.</a:t>
+              <a:t>Keep activities within the allocated phase time.</a:t>
+            </a:r>
+          </a:p>
+          <a:p>
+            <a:r>
+              <a:t>PHASE TIMING: Together, 9:25 AM–9:40 AM. All slides with this phase share these 15 minutes; do not restart the time allocation for each slide.</a:t>
             </a:r>
           </a:p>
         </p:txBody>
@@ -4269,11 +3779,6 @@
               <a:t>Materials/check: Notebook; calculator</a:t>
             </a:r>
           </a:p>
-          <a:p>
-            <a:r>
-              <a:t>Source: 'Math Week 1'!A25:F25</a:t>
-            </a:r>
-          </a:p>
           <a:p/>
           <a:p>
             <a:r>
@@ -4295,11 +3800,6 @@
               <a:t>Materials/check: Identify support needs</a:t>
             </a:r>
           </a:p>
-          <a:p>
-            <a:r>
-              <a:t>Source: 'Math Week 1'!A26:F26</a:t>
-            </a:r>
-          </a:p>
           <a:p/>
           <a:p>
             <a:r>
@@ -4321,11 +3821,6 @@
               <a:t>Materials/check: Textbook; worked example</a:t>
             </a:r>
           </a:p>
-          <a:p>
-            <a:r>
-              <a:t>Source: 'Math Week 1'!A27:F27</a:t>
-            </a:r>
-          </a:p>
           <a:p/>
           <a:p>
             <a:r>
@@ -4347,11 +3842,6 @@
               <a:t>Materials/check: Exercise Book; tool above</a:t>
             </a:r>
           </a:p>
-          <a:p>
-            <a:r>
-              <a:t>Source: 'Math Week 1'!A28:F28</a:t>
-            </a:r>
-          </a:p>
           <a:p/>
           <a:p>
             <a:r>
@@ -4373,11 +3863,6 @@
               <a:t>Materials/check: Paper first; tool second</a:t>
             </a:r>
           </a:p>
-          <a:p>
-            <a:r>
-              <a:t>Source: 'Math Week 1'!A29:F29</a:t>
-            </a:r>
-          </a:p>
           <a:p/>
           <a:p>
             <a:r>
@@ -4399,11 +3884,6 @@
               <a:t>Materials/check: Teacher answers below</a:t>
             </a:r>
           </a:p>
-          <a:p>
-            <a:r>
-              <a:t>Source: 'Math Week 1'!A30:F30</a:t>
-            </a:r>
-          </a:p>
           <a:p/>
           <a:p>
             <a:r>
@@ -4425,11 +3905,6 @@
               <a:t>Materials/check: Notebook / error log</a:t>
             </a:r>
           </a:p>
-          <a:p>
-            <a:r>
-              <a:t>Source: 'Math Week 1'!A31:F31</a:t>
-            </a:r>
-          </a:p>
           <a:p/>
           <a:p>
             <a:r>
@@ -4450,17 +3925,12 @@
           <a:p/>
           <a:p>
             <a:r>
-              <a:t>Sources: 'Math Week 1'!A10:E10; 'Carpentry Schedule'!E3; 'Math Week 1'!A19</a:t>
-            </a:r>
-          </a:p>
-          <a:p>
-            <a:r>
-              <a:t>Navigation/resource slides support these scheduled steps and do not add instructional time.</a:t>
-            </a:r>
-          </a:p>
-          <a:p>
-            <a:r>
-              <a:t>SLIDE PLACEMENT: Together, 9:25 AM–9:40 AM. All slides with this phase share these 15 minutes; do not restart the time allocation for each slide.</a:t>
+              <a:t>Keep activities within the allocated phase time.</a:t>
+            </a:r>
+          </a:p>
+          <a:p>
+            <a:r>
+              <a:t>PHASE TIMING: Together, 9:25 AM–9:40 AM. All slides with this phase share these 15 minutes; do not restart the time allocation for each slide.</a:t>
             </a:r>
           </a:p>
           <a:p/>
@@ -4615,11 +4085,6 @@
               <a:t>Materials/check: Notebook; calculator</a:t>
             </a:r>
           </a:p>
-          <a:p>
-            <a:r>
-              <a:t>Source: 'Math Week 1'!A25:F25</a:t>
-            </a:r>
-          </a:p>
           <a:p/>
           <a:p>
             <a:r>
@@ -4641,11 +4106,6 @@
               <a:t>Materials/check: Identify support needs</a:t>
             </a:r>
           </a:p>
-          <a:p>
-            <a:r>
-              <a:t>Source: 'Math Week 1'!A26:F26</a:t>
-            </a:r>
-          </a:p>
           <a:p/>
           <a:p>
             <a:r>
@@ -4667,11 +4127,6 @@
               <a:t>Materials/check: Textbook; worked example</a:t>
             </a:r>
           </a:p>
-          <a:p>
-            <a:r>
-              <a:t>Source: 'Math Week 1'!A27:F27</a:t>
-            </a:r>
-          </a:p>
           <a:p/>
           <a:p>
             <a:r>
@@ -4693,11 +4148,6 @@
               <a:t>Materials/check: Exercise Book; tool above</a:t>
             </a:r>
           </a:p>
-          <a:p>
-            <a:r>
-              <a:t>Source: 'Math Week 1'!A28:F28</a:t>
-            </a:r>
-          </a:p>
           <a:p/>
           <a:p>
             <a:r>
@@ -4719,11 +4169,6 @@
               <a:t>Materials/check: Paper first; tool second</a:t>
             </a:r>
           </a:p>
-          <a:p>
-            <a:r>
-              <a:t>Source: 'Math Week 1'!A29:F29</a:t>
-            </a:r>
-          </a:p>
           <a:p/>
           <a:p>
             <a:r>
@@ -4745,11 +4190,6 @@
               <a:t>Materials/check: Teacher answers below</a:t>
             </a:r>
           </a:p>
-          <a:p>
-            <a:r>
-              <a:t>Source: 'Math Week 1'!A30:F30</a:t>
-            </a:r>
-          </a:p>
           <a:p/>
           <a:p>
             <a:r>
@@ -4771,11 +4211,6 @@
               <a:t>Materials/check: Notebook / error log</a:t>
             </a:r>
           </a:p>
-          <a:p>
-            <a:r>
-              <a:t>Source: 'Math Week 1'!A31:F31</a:t>
-            </a:r>
-          </a:p>
           <a:p/>
           <a:p>
             <a:r>
@@ -4796,17 +4231,12 @@
           <a:p/>
           <a:p>
             <a:r>
-              <a:t>Sources: 'Math Week 1'!A10:E10; 'Carpentry Schedule'!E3; 'Math Week 1'!A19</a:t>
-            </a:r>
-          </a:p>
-          <a:p>
-            <a:r>
-              <a:t>Navigation/resource slides support these scheduled steps and do not add instructional time.</a:t>
-            </a:r>
-          </a:p>
-          <a:p>
-            <a:r>
-              <a:t>SLIDE PLACEMENT: Together, 9:25 AM–9:40 AM. All slides with this phase share these 15 minutes; do not restart the time allocation for each slide.</a:t>
+              <a:t>Keep activities within the allocated phase time.</a:t>
+            </a:r>
+          </a:p>
+          <a:p>
+            <a:r>
+              <a:t>PHASE TIMING: Together, 9:25 AM–9:40 AM. All slides with this phase share these 15 minutes; do not restart the time allocation for each slide.</a:t>
             </a:r>
           </a:p>
           <a:p/>
@@ -4961,11 +4391,6 @@
               <a:t>Materials/check: Notebook; calculator</a:t>
             </a:r>
           </a:p>
-          <a:p>
-            <a:r>
-              <a:t>Source: 'Math Week 1'!A25:F25</a:t>
-            </a:r>
-          </a:p>
           <a:p/>
           <a:p>
             <a:r>
@@ -4987,11 +4412,6 @@
               <a:t>Materials/check: Identify support needs</a:t>
             </a:r>
           </a:p>
-          <a:p>
-            <a:r>
-              <a:t>Source: 'Math Week 1'!A26:F26</a:t>
-            </a:r>
-          </a:p>
           <a:p/>
           <a:p>
             <a:r>
@@ -5013,11 +4433,6 @@
               <a:t>Materials/check: Textbook; worked example</a:t>
             </a:r>
           </a:p>
-          <a:p>
-            <a:r>
-              <a:t>Source: 'Math Week 1'!A27:F27</a:t>
-            </a:r>
-          </a:p>
           <a:p/>
           <a:p>
             <a:r>
@@ -5039,11 +4454,6 @@
               <a:t>Materials/check: Exercise Book; tool above</a:t>
             </a:r>
           </a:p>
-          <a:p>
-            <a:r>
-              <a:t>Source: 'Math Week 1'!A28:F28</a:t>
-            </a:r>
-          </a:p>
           <a:p/>
           <a:p>
             <a:r>
@@ -5065,11 +4475,6 @@
               <a:t>Materials/check: Paper first; tool second</a:t>
             </a:r>
           </a:p>
-          <a:p>
-            <a:r>
-              <a:t>Source: 'Math Week 1'!A29:F29</a:t>
-            </a:r>
-          </a:p>
           <a:p/>
           <a:p>
             <a:r>
@@ -5091,11 +4496,6 @@
               <a:t>Materials/check: Teacher answers below</a:t>
             </a:r>
           </a:p>
-          <a:p>
-            <a:r>
-              <a:t>Source: 'Math Week 1'!A30:F30</a:t>
-            </a:r>
-          </a:p>
           <a:p/>
           <a:p>
             <a:r>
@@ -5117,11 +4517,6 @@
               <a:t>Materials/check: Notebook / error log</a:t>
             </a:r>
           </a:p>
-          <a:p>
-            <a:r>
-              <a:t>Source: 'Math Week 1'!A31:F31</a:t>
-            </a:r>
-          </a:p>
           <a:p/>
           <a:p>
             <a:r>
@@ -5142,17 +4537,12 @@
           <a:p/>
           <a:p>
             <a:r>
-              <a:t>Sources: 'Math Week 1'!A10:E10; 'Carpentry Schedule'!E3; 'Math Week 1'!A19</a:t>
-            </a:r>
-          </a:p>
-          <a:p>
-            <a:r>
-              <a:t>Navigation/resource slides support these scheduled steps and do not add instructional time.</a:t>
-            </a:r>
-          </a:p>
-          <a:p>
-            <a:r>
-              <a:t>SLIDE PLACEMENT: Practise, 9:40 AM–10:00 AM. All slides with this phase share these 20 minutes; do not restart the time allocation for each slide.</a:t>
+              <a:t>Keep activities within the allocated phase time.</a:t>
+            </a:r>
+          </a:p>
+          <a:p>
+            <a:r>
+              <a:t>PHASE TIMING: Practise, 9:40 AM–10:00 AM. All slides with this phase share these 20 minutes; do not restart the time allocation for each slide.</a:t>
             </a:r>
           </a:p>
         </p:txBody>
@@ -5281,11 +4671,6 @@
               <a:t>Materials/check: Notebook; calculator</a:t>
             </a:r>
           </a:p>
-          <a:p>
-            <a:r>
-              <a:t>Source: 'Math Week 1'!A25:F25</a:t>
-            </a:r>
-          </a:p>
           <a:p/>
           <a:p>
             <a:r>
@@ -5307,11 +4692,6 @@
               <a:t>Materials/check: Identify support needs</a:t>
             </a:r>
           </a:p>
-          <a:p>
-            <a:r>
-              <a:t>Source: 'Math Week 1'!A26:F26</a:t>
-            </a:r>
-          </a:p>
           <a:p/>
           <a:p>
             <a:r>
@@ -5333,11 +4713,6 @@
               <a:t>Materials/check: Textbook; worked example</a:t>
             </a:r>
           </a:p>
-          <a:p>
-            <a:r>
-              <a:t>Source: 'Math Week 1'!A27:F27</a:t>
-            </a:r>
-          </a:p>
           <a:p/>
           <a:p>
             <a:r>
@@ -5359,11 +4734,6 @@
               <a:t>Materials/check: Exercise Book; tool above</a:t>
             </a:r>
           </a:p>
-          <a:p>
-            <a:r>
-              <a:t>Source: 'Math Week 1'!A28:F28</a:t>
-            </a:r>
-          </a:p>
           <a:p/>
           <a:p>
             <a:r>
@@ -5385,11 +4755,6 @@
               <a:t>Materials/check: Paper first; tool second</a:t>
             </a:r>
           </a:p>
-          <a:p>
-            <a:r>
-              <a:t>Source: 'Math Week 1'!A29:F29</a:t>
-            </a:r>
-          </a:p>
           <a:p/>
           <a:p>
             <a:r>
@@ -5411,11 +4776,6 @@
               <a:t>Materials/check: Teacher answers below</a:t>
             </a:r>
           </a:p>
-          <a:p>
-            <a:r>
-              <a:t>Source: 'Math Week 1'!A30:F30</a:t>
-            </a:r>
-          </a:p>
           <a:p/>
           <a:p>
             <a:r>
@@ -5437,11 +4797,6 @@
               <a:t>Materials/check: Notebook / error log</a:t>
             </a:r>
           </a:p>
-          <a:p>
-            <a:r>
-              <a:t>Source: 'Math Week 1'!A31:F31</a:t>
-            </a:r>
-          </a:p>
           <a:p/>
           <a:p>
             <a:r>
@@ -5462,23 +4817,18 @@
           <a:p/>
           <a:p>
             <a:r>
-              <a:t>Sources: 'Math Week 1'!A10:E10; 'Carpentry Schedule'!E3; 'Math Week 1'!A19</a:t>
-            </a:r>
-          </a:p>
-          <a:p>
-            <a:r>
-              <a:t>Navigation/resource slides support these scheduled steps and do not add instructional time.</a:t>
-            </a:r>
-          </a:p>
-          <a:p>
-            <a:r>
-              <a:t>SLIDE PLACEMENT: Practise, 9:40 AM–10:00 AM. All slides with this phase share these 20 minutes; do not restart the time allocation for each slide.</a:t>
-            </a:r>
-          </a:p>
-          <a:p/>
-          <a:p>
-            <a:r>
-              <a:t>Live-tool screenshot, not an answer to the scheduled task. Open the resource link and follow the exact values in the assignment. Keep worked answers hidden until learners attempt the task. Screenshot illustrates navigation and occupies time within the same scheduled practice phase.</a:t>
+              <a:t>Keep activities within the allocated phase time.</a:t>
+            </a:r>
+          </a:p>
+          <a:p>
+            <a:r>
+              <a:t>PHASE TIMING: Practise, 9:40 AM–10:00 AM. All slides with this phase share these 20 minutes; do not restart the time allocation for each slide.</a:t>
+            </a:r>
+          </a:p>
+          <a:p/>
+          <a:p>
+            <a:r>
+              <a:t>Demonstrate navigation, then open the tool and use the assigned values. Keep worked answers hidden until learners attempt the task. Include this activity within the allocated practice time.</a:t>
             </a:r>
           </a:p>
         </p:txBody>
@@ -5607,11 +4957,6 @@
               <a:t>Materials/check: Notebook; calculator</a:t>
             </a:r>
           </a:p>
-          <a:p>
-            <a:r>
-              <a:t>Source: 'Math Week 1'!A25:F25</a:t>
-            </a:r>
-          </a:p>
           <a:p/>
           <a:p>
             <a:r>
@@ -5633,11 +4978,6 @@
               <a:t>Materials/check: Identify support needs</a:t>
             </a:r>
           </a:p>
-          <a:p>
-            <a:r>
-              <a:t>Source: 'Math Week 1'!A26:F26</a:t>
-            </a:r>
-          </a:p>
           <a:p/>
           <a:p>
             <a:r>
@@ -5659,11 +4999,6 @@
               <a:t>Materials/check: Textbook; worked example</a:t>
             </a:r>
           </a:p>
-          <a:p>
-            <a:r>
-              <a:t>Source: 'Math Week 1'!A27:F27</a:t>
-            </a:r>
-          </a:p>
           <a:p/>
           <a:p>
             <a:r>
@@ -5685,11 +5020,6 @@
               <a:t>Materials/check: Exercise Book; tool above</a:t>
             </a:r>
           </a:p>
-          <a:p>
-            <a:r>
-              <a:t>Source: 'Math Week 1'!A28:F28</a:t>
-            </a:r>
-          </a:p>
           <a:p/>
           <a:p>
             <a:r>
@@ -5711,11 +5041,6 @@
               <a:t>Materials/check: Paper first; tool second</a:t>
             </a:r>
           </a:p>
-          <a:p>
-            <a:r>
-              <a:t>Source: 'Math Week 1'!A29:F29</a:t>
-            </a:r>
-          </a:p>
           <a:p/>
           <a:p>
             <a:r>
@@ -5737,11 +5062,6 @@
               <a:t>Materials/check: Teacher answers below</a:t>
             </a:r>
           </a:p>
-          <a:p>
-            <a:r>
-              <a:t>Source: 'Math Week 1'!A30:F30</a:t>
-            </a:r>
-          </a:p>
           <a:p/>
           <a:p>
             <a:r>
@@ -5763,11 +5083,6 @@
               <a:t>Materials/check: Notebook / error log</a:t>
             </a:r>
           </a:p>
-          <a:p>
-            <a:r>
-              <a:t>Source: 'Math Week 1'!A31:F31</a:t>
-            </a:r>
-          </a:p>
           <a:p/>
           <a:p>
             <a:r>
@@ -5788,17 +5103,12 @@
           <a:p/>
           <a:p>
             <a:r>
-              <a:t>Sources: 'Math Week 1'!A10:E10; 'Carpentry Schedule'!E3; 'Math Week 1'!A19</a:t>
-            </a:r>
-          </a:p>
-          <a:p>
-            <a:r>
-              <a:t>Navigation/resource slides support these scheduled steps and do not add instructional time.</a:t>
-            </a:r>
-          </a:p>
-          <a:p>
-            <a:r>
-              <a:t>SLIDE PLACEMENT: Practise, 9:40 AM–10:00 AM. All slides with this phase share these 20 minutes; do not restart the time allocation for each slide.</a:t>
+              <a:t>Keep activities within the allocated phase time.</a:t>
+            </a:r>
+          </a:p>
+          <a:p>
+            <a:r>
+              <a:t>PHASE TIMING: Practise, 9:40 AM–10:00 AM. All slides with this phase share these 20 minutes; do not restart the time allocation for each slide.</a:t>
             </a:r>
           </a:p>
           <a:p/>
@@ -5948,11 +5258,6 @@
               <a:t>Materials/check: Notebook; calculator</a:t>
             </a:r>
           </a:p>
-          <a:p>
-            <a:r>
-              <a:t>Source: 'Math Week 1'!A25:F25</a:t>
-            </a:r>
-          </a:p>
           <a:p/>
           <a:p>
             <a:r>
@@ -5974,11 +5279,6 @@
               <a:t>Materials/check: Identify support needs</a:t>
             </a:r>
           </a:p>
-          <a:p>
-            <a:r>
-              <a:t>Source: 'Math Week 1'!A26:F26</a:t>
-            </a:r>
-          </a:p>
           <a:p/>
           <a:p>
             <a:r>
@@ -6000,11 +5300,6 @@
               <a:t>Materials/check: Textbook; worked example</a:t>
             </a:r>
           </a:p>
-          <a:p>
-            <a:r>
-              <a:t>Source: 'Math Week 1'!A27:F27</a:t>
-            </a:r>
-          </a:p>
           <a:p/>
           <a:p>
             <a:r>
@@ -6026,11 +5321,6 @@
               <a:t>Materials/check: Exercise Book; tool above</a:t>
             </a:r>
           </a:p>
-          <a:p>
-            <a:r>
-              <a:t>Source: 'Math Week 1'!A28:F28</a:t>
-            </a:r>
-          </a:p>
           <a:p/>
           <a:p>
             <a:r>
@@ -6052,11 +5342,6 @@
               <a:t>Materials/check: Paper first; tool second</a:t>
             </a:r>
           </a:p>
-          <a:p>
-            <a:r>
-              <a:t>Source: 'Math Week 1'!A29:F29</a:t>
-            </a:r>
-          </a:p>
           <a:p/>
           <a:p>
             <a:r>
@@ -6078,11 +5363,6 @@
               <a:t>Materials/check: Teacher answers below</a:t>
             </a:r>
           </a:p>
-          <a:p>
-            <a:r>
-              <a:t>Source: 'Math Week 1'!A30:F30</a:t>
-            </a:r>
-          </a:p>
           <a:p/>
           <a:p>
             <a:r>
@@ -6104,11 +5384,6 @@
               <a:t>Materials/check: Notebook / error log</a:t>
             </a:r>
           </a:p>
-          <a:p>
-            <a:r>
-              <a:t>Source: 'Math Week 1'!A31:F31</a:t>
-            </a:r>
-          </a:p>
           <a:p/>
           <a:p>
             <a:r>
@@ -6129,17 +5404,12 @@
           <a:p/>
           <a:p>
             <a:r>
-              <a:t>Sources: 'Math Week 1'!A10:E10; 'Carpentry Schedule'!E3; 'Math Week 1'!A19</a:t>
-            </a:r>
-          </a:p>
-          <a:p>
-            <a:r>
-              <a:t>Navigation/resource slides support these scheduled steps and do not add instructional time.</a:t>
-            </a:r>
-          </a:p>
-          <a:p>
-            <a:r>
-              <a:t>SLIDE PLACEMENT: Practise, 9:40 AM–10:00 AM. All slides with this phase share these 20 minutes; do not restart the time allocation for each slide.</a:t>
+              <a:t>Keep activities within the allocated phase time.</a:t>
+            </a:r>
+          </a:p>
+          <a:p>
+            <a:r>
+              <a:t>PHASE TIMING: Practise, 9:40 AM–10:00 AM. All slides with this phase share these 20 minutes; do not restart the time allocation for each slide.</a:t>
             </a:r>
           </a:p>
           <a:p/>
@@ -6294,11 +5564,6 @@
               <a:t>Materials/check: Notebook; calculator</a:t>
             </a:r>
           </a:p>
-          <a:p>
-            <a:r>
-              <a:t>Source: 'Math Week 1'!A25:F25</a:t>
-            </a:r>
-          </a:p>
           <a:p/>
           <a:p>
             <a:r>
@@ -6320,11 +5585,6 @@
               <a:t>Materials/check: Identify support needs</a:t>
             </a:r>
           </a:p>
-          <a:p>
-            <a:r>
-              <a:t>Source: 'Math Week 1'!A26:F26</a:t>
-            </a:r>
-          </a:p>
           <a:p/>
           <a:p>
             <a:r>
@@ -6346,11 +5606,6 @@
               <a:t>Materials/check: Textbook; worked example</a:t>
             </a:r>
           </a:p>
-          <a:p>
-            <a:r>
-              <a:t>Source: 'Math Week 1'!A27:F27</a:t>
-            </a:r>
-          </a:p>
           <a:p/>
           <a:p>
             <a:r>
@@ -6372,11 +5627,6 @@
               <a:t>Materials/check: Exercise Book; tool above</a:t>
             </a:r>
           </a:p>
-          <a:p>
-            <a:r>
-              <a:t>Source: 'Math Week 1'!A28:F28</a:t>
-            </a:r>
-          </a:p>
           <a:p/>
           <a:p>
             <a:r>
@@ -6398,11 +5648,6 @@
               <a:t>Materials/check: Paper first; tool second</a:t>
             </a:r>
           </a:p>
-          <a:p>
-            <a:r>
-              <a:t>Source: 'Math Week 1'!A29:F29</a:t>
-            </a:r>
-          </a:p>
           <a:p/>
           <a:p>
             <a:r>
@@ -6424,11 +5669,6 @@
               <a:t>Materials/check: Teacher answers below</a:t>
             </a:r>
           </a:p>
-          <a:p>
-            <a:r>
-              <a:t>Source: 'Math Week 1'!A30:F30</a:t>
-            </a:r>
-          </a:p>
           <a:p/>
           <a:p>
             <a:r>
@@ -6450,11 +5690,6 @@
               <a:t>Materials/check: Notebook / error log</a:t>
             </a:r>
           </a:p>
-          <a:p>
-            <a:r>
-              <a:t>Source: 'Math Week 1'!A31:F31</a:t>
-            </a:r>
-          </a:p>
           <a:p/>
           <a:p>
             <a:r>
@@ -6475,17 +5710,12 @@
           <a:p/>
           <a:p>
             <a:r>
-              <a:t>Sources: 'Math Week 1'!A10:E10; 'Carpentry Schedule'!E3; 'Math Week 1'!A19</a:t>
-            </a:r>
-          </a:p>
-          <a:p>
-            <a:r>
-              <a:t>Navigation/resource slides support these scheduled steps and do not add instructional time.</a:t>
-            </a:r>
-          </a:p>
-          <a:p>
-            <a:r>
-              <a:t>SLIDE PLACEMENT: Practise, 9:40 AM–10:00 AM. All slides with this phase share these 20 minutes; do not restart the time allocation for each slide.</a:t>
+              <a:t>Keep activities within the allocated phase time.</a:t>
+            </a:r>
+          </a:p>
+          <a:p>
+            <a:r>
+              <a:t>PHASE TIMING: Practise, 9:40 AM–10:00 AM. All slides with this phase share these 20 minutes; do not restart the time allocation for each slide.</a:t>
             </a:r>
           </a:p>
           <a:p/>
@@ -6640,11 +5870,6 @@
               <a:t>Materials/check: Notebook; calculator</a:t>
             </a:r>
           </a:p>
-          <a:p>
-            <a:r>
-              <a:t>Source: 'Math Week 1'!A25:F25</a:t>
-            </a:r>
-          </a:p>
           <a:p/>
           <a:p>
             <a:r>
@@ -6666,11 +5891,6 @@
               <a:t>Materials/check: Identify support needs</a:t>
             </a:r>
           </a:p>
-          <a:p>
-            <a:r>
-              <a:t>Source: 'Math Week 1'!A26:F26</a:t>
-            </a:r>
-          </a:p>
           <a:p/>
           <a:p>
             <a:r>
@@ -6692,11 +5912,6 @@
               <a:t>Materials/check: Textbook; worked example</a:t>
             </a:r>
           </a:p>
-          <a:p>
-            <a:r>
-              <a:t>Source: 'Math Week 1'!A27:F27</a:t>
-            </a:r>
-          </a:p>
           <a:p/>
           <a:p>
             <a:r>
@@ -6718,11 +5933,6 @@
               <a:t>Materials/check: Exercise Book; tool above</a:t>
             </a:r>
           </a:p>
-          <a:p>
-            <a:r>
-              <a:t>Source: 'Math Week 1'!A28:F28</a:t>
-            </a:r>
-          </a:p>
           <a:p/>
           <a:p>
             <a:r>
@@ -6744,11 +5954,6 @@
               <a:t>Materials/check: Paper first; tool second</a:t>
             </a:r>
           </a:p>
-          <a:p>
-            <a:r>
-              <a:t>Source: 'Math Week 1'!A29:F29</a:t>
-            </a:r>
-          </a:p>
           <a:p/>
           <a:p>
             <a:r>
@@ -6770,11 +5975,6 @@
               <a:t>Materials/check: Teacher answers below</a:t>
             </a:r>
           </a:p>
-          <a:p>
-            <a:r>
-              <a:t>Source: 'Math Week 1'!A30:F30</a:t>
-            </a:r>
-          </a:p>
           <a:p/>
           <a:p>
             <a:r>
@@ -6796,11 +5996,6 @@
               <a:t>Materials/check: Notebook / error log</a:t>
             </a:r>
           </a:p>
-          <a:p>
-            <a:r>
-              <a:t>Source: 'Math Week 1'!A31:F31</a:t>
-            </a:r>
-          </a:p>
           <a:p/>
           <a:p>
             <a:r>
@@ -6821,17 +6016,12 @@
           <a:p/>
           <a:p>
             <a:r>
-              <a:t>Sources: 'Math Week 1'!A10:E10; 'Carpentry Schedule'!E3; 'Math Week 1'!A19</a:t>
-            </a:r>
-          </a:p>
-          <a:p>
-            <a:r>
-              <a:t>Navigation/resource slides support these scheduled steps and do not add instructional time.</a:t>
-            </a:r>
-          </a:p>
-          <a:p>
-            <a:r>
-              <a:t>SLIDE PLACEMENT: Check, 10:00 AM–10:10 AM. All slides with this phase share these 10 minutes; do not restart the time allocation for each slide.</a:t>
+              <a:t>Keep activities within the allocated phase time.</a:t>
+            </a:r>
+          </a:p>
+          <a:p>
+            <a:r>
+              <a:t>PHASE TIMING: Check, 10:00 AM–10:10 AM. All slides with this phase share these 10 minutes; do not restart the time allocation for each slide.</a:t>
             </a:r>
           </a:p>
         </p:txBody>
@@ -6960,11 +6150,6 @@
               <a:t>Materials/check: Notebook; calculator</a:t>
             </a:r>
           </a:p>
-          <a:p>
-            <a:r>
-              <a:t>Source: 'Math Week 1'!A25:F25</a:t>
-            </a:r>
-          </a:p>
           <a:p/>
           <a:p>
             <a:r>
@@ -6986,11 +6171,6 @@
               <a:t>Materials/check: Identify support needs</a:t>
             </a:r>
           </a:p>
-          <a:p>
-            <a:r>
-              <a:t>Source: 'Math Week 1'!A26:F26</a:t>
-            </a:r>
-          </a:p>
           <a:p/>
           <a:p>
             <a:r>
@@ -7012,11 +6192,6 @@
               <a:t>Materials/check: Textbook; worked example</a:t>
             </a:r>
           </a:p>
-          <a:p>
-            <a:r>
-              <a:t>Source: 'Math Week 1'!A27:F27</a:t>
-            </a:r>
-          </a:p>
           <a:p/>
           <a:p>
             <a:r>
@@ -7038,11 +6213,6 @@
               <a:t>Materials/check: Exercise Book; tool above</a:t>
             </a:r>
           </a:p>
-          <a:p>
-            <a:r>
-              <a:t>Source: 'Math Week 1'!A28:F28</a:t>
-            </a:r>
-          </a:p>
           <a:p/>
           <a:p>
             <a:r>
@@ -7064,11 +6234,6 @@
               <a:t>Materials/check: Paper first; tool second</a:t>
             </a:r>
           </a:p>
-          <a:p>
-            <a:r>
-              <a:t>Source: 'Math Week 1'!A29:F29</a:t>
-            </a:r>
-          </a:p>
           <a:p/>
           <a:p>
             <a:r>
@@ -7090,11 +6255,6 @@
               <a:t>Materials/check: Teacher answers below</a:t>
             </a:r>
           </a:p>
-          <a:p>
-            <a:r>
-              <a:t>Source: 'Math Week 1'!A30:F30</a:t>
-            </a:r>
-          </a:p>
           <a:p/>
           <a:p>
             <a:r>
@@ -7116,11 +6276,6 @@
               <a:t>Materials/check: Notebook / error log</a:t>
             </a:r>
           </a:p>
-          <a:p>
-            <a:r>
-              <a:t>Source: 'Math Week 1'!A31:F31</a:t>
-            </a:r>
-          </a:p>
           <a:p/>
           <a:p>
             <a:r>
@@ -7141,17 +6296,12 @@
           <a:p/>
           <a:p>
             <a:r>
-              <a:t>Sources: 'Math Week 1'!A10:E10; 'Carpentry Schedule'!E3; 'Math Week 1'!A19</a:t>
-            </a:r>
-          </a:p>
-          <a:p>
-            <a:r>
-              <a:t>Navigation/resource slides support these scheduled steps and do not add instructional time.</a:t>
-            </a:r>
-          </a:p>
-          <a:p>
-            <a:r>
-              <a:t>SLIDE PLACEMENT: Check, 10:00 AM–10:10 AM. All slides with this phase share these 10 minutes; do not restart the time allocation for each slide.</a:t>
+              <a:t>Keep activities within the allocated phase time.</a:t>
+            </a:r>
+          </a:p>
+          <a:p>
+            <a:r>
+              <a:t>PHASE TIMING: Check, 10:00 AM–10:10 AM. All slides with this phase share these 10 minutes; do not restart the time allocation for each slide.</a:t>
             </a:r>
           </a:p>
           <a:p/>
@@ -7306,11 +6456,6 @@
               <a:t>Materials/check: Notebook; calculator</a:t>
             </a:r>
           </a:p>
-          <a:p>
-            <a:r>
-              <a:t>Source: 'Math Week 1'!A25:F25</a:t>
-            </a:r>
-          </a:p>
           <a:p/>
           <a:p>
             <a:r>
@@ -7332,11 +6477,6 @@
               <a:t>Materials/check: Identify support needs</a:t>
             </a:r>
           </a:p>
-          <a:p>
-            <a:r>
-              <a:t>Source: 'Math Week 1'!A26:F26</a:t>
-            </a:r>
-          </a:p>
           <a:p/>
           <a:p>
             <a:r>
@@ -7358,11 +6498,6 @@
               <a:t>Materials/check: Textbook; worked example</a:t>
             </a:r>
           </a:p>
-          <a:p>
-            <a:r>
-              <a:t>Source: 'Math Week 1'!A27:F27</a:t>
-            </a:r>
-          </a:p>
           <a:p/>
           <a:p>
             <a:r>
@@ -7384,11 +6519,6 @@
               <a:t>Materials/check: Exercise Book; tool above</a:t>
             </a:r>
           </a:p>
-          <a:p>
-            <a:r>
-              <a:t>Source: 'Math Week 1'!A28:F28</a:t>
-            </a:r>
-          </a:p>
           <a:p/>
           <a:p>
             <a:r>
@@ -7410,11 +6540,6 @@
               <a:t>Materials/check: Paper first; tool second</a:t>
             </a:r>
           </a:p>
-          <a:p>
-            <a:r>
-              <a:t>Source: 'Math Week 1'!A29:F29</a:t>
-            </a:r>
-          </a:p>
           <a:p/>
           <a:p>
             <a:r>
@@ -7436,11 +6561,6 @@
               <a:t>Materials/check: Teacher answers below</a:t>
             </a:r>
           </a:p>
-          <a:p>
-            <a:r>
-              <a:t>Source: 'Math Week 1'!A30:F30</a:t>
-            </a:r>
-          </a:p>
           <a:p/>
           <a:p>
             <a:r>
@@ -7462,11 +6582,6 @@
               <a:t>Materials/check: Notebook / error log</a:t>
             </a:r>
           </a:p>
-          <a:p>
-            <a:r>
-              <a:t>Source: 'Math Week 1'!A31:F31</a:t>
-            </a:r>
-          </a:p>
           <a:p/>
           <a:p>
             <a:r>
@@ -7487,17 +6602,12 @@
           <a:p/>
           <a:p>
             <a:r>
-              <a:t>Sources: 'Math Week 1'!A10:E10; 'Carpentry Schedule'!E3; 'Math Week 1'!A19</a:t>
-            </a:r>
-          </a:p>
-          <a:p>
-            <a:r>
-              <a:t>Navigation/resource slides support these scheduled steps and do not add instructional time.</a:t>
-            </a:r>
-          </a:p>
-          <a:p>
-            <a:r>
-              <a:t>SLIDE PLACEMENT: Check, 10:00 AM–10:10 AM. All slides with this phase share these 10 minutes; do not restart the time allocation for each slide.</a:t>
+              <a:t>Keep activities within the allocated phase time.</a:t>
+            </a:r>
+          </a:p>
+          <a:p>
+            <a:r>
+              <a:t>PHASE TIMING: Check, 10:00 AM–10:10 AM. All slides with this phase share these 10 minutes; do not restart the time allocation for each slide.</a:t>
             </a:r>
           </a:p>
           <a:p/>
@@ -7652,11 +6762,6 @@
               <a:t>Materials/check: Notebook; calculator</a:t>
             </a:r>
           </a:p>
-          <a:p>
-            <a:r>
-              <a:t>Source: 'Math Week 1'!A25:F25</a:t>
-            </a:r>
-          </a:p>
           <a:p/>
           <a:p>
             <a:r>
@@ -7678,11 +6783,6 @@
               <a:t>Materials/check: Identify support needs</a:t>
             </a:r>
           </a:p>
-          <a:p>
-            <a:r>
-              <a:t>Source: 'Math Week 1'!A26:F26</a:t>
-            </a:r>
-          </a:p>
           <a:p/>
           <a:p>
             <a:r>
@@ -7704,11 +6804,6 @@
               <a:t>Materials/check: Textbook; worked example</a:t>
             </a:r>
           </a:p>
-          <a:p>
-            <a:r>
-              <a:t>Source: 'Math Week 1'!A27:F27</a:t>
-            </a:r>
-          </a:p>
           <a:p/>
           <a:p>
             <a:r>
@@ -7730,11 +6825,6 @@
               <a:t>Materials/check: Exercise Book; tool above</a:t>
             </a:r>
           </a:p>
-          <a:p>
-            <a:r>
-              <a:t>Source: 'Math Week 1'!A28:F28</a:t>
-            </a:r>
-          </a:p>
           <a:p/>
           <a:p>
             <a:r>
@@ -7756,11 +6846,6 @@
               <a:t>Materials/check: Paper first; tool second</a:t>
             </a:r>
           </a:p>
-          <a:p>
-            <a:r>
-              <a:t>Source: 'Math Week 1'!A29:F29</a:t>
-            </a:r>
-          </a:p>
           <a:p/>
           <a:p>
             <a:r>
@@ -7782,11 +6867,6 @@
               <a:t>Materials/check: Teacher answers below</a:t>
             </a:r>
           </a:p>
-          <a:p>
-            <a:r>
-              <a:t>Source: 'Math Week 1'!A30:F30</a:t>
-            </a:r>
-          </a:p>
           <a:p/>
           <a:p>
             <a:r>
@@ -7808,11 +6888,6 @@
               <a:t>Materials/check: Notebook / error log</a:t>
             </a:r>
           </a:p>
-          <a:p>
-            <a:r>
-              <a:t>Source: 'Math Week 1'!A31:F31</a:t>
-            </a:r>
-          </a:p>
           <a:p/>
           <a:p>
             <a:r>
@@ -7833,17 +6908,12 @@
           <a:p/>
           <a:p>
             <a:r>
-              <a:t>Sources: 'Math Week 1'!A10:E10; 'Carpentry Schedule'!E3; 'Math Week 1'!A19</a:t>
-            </a:r>
-          </a:p>
-          <a:p>
-            <a:r>
-              <a:t>Navigation/resource slides support these scheduled steps and do not add instructional time.</a:t>
-            </a:r>
-          </a:p>
-          <a:p>
-            <a:r>
-              <a:t>SLIDE PLACEMENT: Wrap up, 10:10 AM–10:15 AM. All slides with this phase share these 5 minutes; do not restart the time allocation for each slide.</a:t>
+              <a:t>Keep activities within the allocated phase time.</a:t>
+            </a:r>
+          </a:p>
+          <a:p>
+            <a:r>
+              <a:t>PHASE TIMING: Wrap up, 10:10 AM–10:15 AM. All slides with this phase share these 5 minutes; do not restart the time allocation for each slide.</a:t>
             </a:r>
           </a:p>
           <a:p/>
@@ -8048,11 +7118,6 @@
               <a:t>Materials/check: Notebook; calculator</a:t>
             </a:r>
           </a:p>
-          <a:p>
-            <a:r>
-              <a:t>Source: 'Math Week 1'!A42:F42</a:t>
-            </a:r>
-          </a:p>
           <a:p/>
           <a:p>
             <a:r>
@@ -8074,11 +7139,6 @@
               <a:t>Materials/check: Identify support needs</a:t>
             </a:r>
           </a:p>
-          <a:p>
-            <a:r>
-              <a:t>Source: 'Math Week 1'!A43:F43</a:t>
-            </a:r>
-          </a:p>
           <a:p/>
           <a:p>
             <a:r>
@@ -8100,11 +7160,6 @@
               <a:t>Materials/check: Textbook; worked example</a:t>
             </a:r>
           </a:p>
-          <a:p>
-            <a:r>
-              <a:t>Source: 'Math Week 1'!A44:F44</a:t>
-            </a:r>
-          </a:p>
           <a:p/>
           <a:p>
             <a:r>
@@ -8126,11 +7181,6 @@
               <a:t>Materials/check: Exercise Book; tool above</a:t>
             </a:r>
           </a:p>
-          <a:p>
-            <a:r>
-              <a:t>Source: 'Math Week 1'!A45:F45</a:t>
-            </a:r>
-          </a:p>
           <a:p/>
           <a:p>
             <a:r>
@@ -8152,11 +7202,6 @@
               <a:t>Materials/check: Paper first; tool second</a:t>
             </a:r>
           </a:p>
-          <a:p>
-            <a:r>
-              <a:t>Source: 'Math Week 1'!A46:F46</a:t>
-            </a:r>
-          </a:p>
           <a:p/>
           <a:p>
             <a:r>
@@ -8178,11 +7223,6 @@
               <a:t>Materials/check: Teacher answers below</a:t>
             </a:r>
           </a:p>
-          <a:p>
-            <a:r>
-              <a:t>Source: 'Math Week 1'!A47:F47</a:t>
-            </a:r>
-          </a:p>
           <a:p/>
           <a:p>
             <a:r>
@@ -8204,11 +7244,6 @@
               <a:t>Materials/check: Notebook / error log</a:t>
             </a:r>
           </a:p>
-          <a:p>
-            <a:r>
-              <a:t>Source: 'Math Week 1'!A48:F48</a:t>
-            </a:r>
-          </a:p>
           <a:p/>
           <a:p>
             <a:r>
@@ -8229,17 +7264,12 @@
           <a:p/>
           <a:p>
             <a:r>
-              <a:t>Sources: 'Math Week 1'!A11:E11; 'Carpentry Schedule'!E5; 'Math Week 1'!A36</a:t>
-            </a:r>
-          </a:p>
-          <a:p>
-            <a:r>
-              <a:t>Navigation/resource slides support these scheduled steps and do not add instructional time.</a:t>
-            </a:r>
-          </a:p>
-          <a:p>
-            <a:r>
-              <a:t>SLIDE PLACEMENT: Start, 10:30 AM–10:35 AM. All slides with this phase share these 5 minutes; do not restart the time allocation for each slide.</a:t>
+              <a:t>Keep activities within the allocated phase time.</a:t>
+            </a:r>
+          </a:p>
+          <a:p>
+            <a:r>
+              <a:t>PHASE TIMING: Start, 10:30 AM–10:35 AM. All slides with this phase share these 5 minutes; do not restart the time allocation for each slide.</a:t>
             </a:r>
           </a:p>
         </p:txBody>
@@ -8368,11 +7398,6 @@
               <a:t>Materials/check: Notebook; calculator</a:t>
             </a:r>
           </a:p>
-          <a:p>
-            <a:r>
-              <a:t>Source: 'Math Week 1'!A42:F42</a:t>
-            </a:r>
-          </a:p>
           <a:p/>
           <a:p>
             <a:r>
@@ -8394,11 +7419,6 @@
               <a:t>Materials/check: Identify support needs</a:t>
             </a:r>
           </a:p>
-          <a:p>
-            <a:r>
-              <a:t>Source: 'Math Week 1'!A43:F43</a:t>
-            </a:r>
-          </a:p>
           <a:p/>
           <a:p>
             <a:r>
@@ -8420,11 +7440,6 @@
               <a:t>Materials/check: Textbook; worked example</a:t>
             </a:r>
           </a:p>
-          <a:p>
-            <a:r>
-              <a:t>Source: 'Math Week 1'!A44:F44</a:t>
-            </a:r>
-          </a:p>
           <a:p/>
           <a:p>
             <a:r>
@@ -8446,11 +7461,6 @@
               <a:t>Materials/check: Exercise Book; tool above</a:t>
             </a:r>
           </a:p>
-          <a:p>
-            <a:r>
-              <a:t>Source: 'Math Week 1'!A45:F45</a:t>
-            </a:r>
-          </a:p>
           <a:p/>
           <a:p>
             <a:r>
@@ -8472,11 +7482,6 @@
               <a:t>Materials/check: Paper first; tool second</a:t>
             </a:r>
           </a:p>
-          <a:p>
-            <a:r>
-              <a:t>Source: 'Math Week 1'!A46:F46</a:t>
-            </a:r>
-          </a:p>
           <a:p/>
           <a:p>
             <a:r>
@@ -8498,11 +7503,6 @@
               <a:t>Materials/check: Teacher answers below</a:t>
             </a:r>
           </a:p>
-          <a:p>
-            <a:r>
-              <a:t>Source: 'Math Week 1'!A47:F47</a:t>
-            </a:r>
-          </a:p>
           <a:p/>
           <a:p>
             <a:r>
@@ -8524,11 +7524,6 @@
               <a:t>Materials/check: Notebook / error log</a:t>
             </a:r>
           </a:p>
-          <a:p>
-            <a:r>
-              <a:t>Source: 'Math Week 1'!A48:F48</a:t>
-            </a:r>
-          </a:p>
           <a:p/>
           <a:p>
             <a:r>
@@ -8549,17 +7544,12 @@
           <a:p/>
           <a:p>
             <a:r>
-              <a:t>Sources: 'Math Week 1'!A11:E11; 'Carpentry Schedule'!E5; 'Math Week 1'!A36</a:t>
-            </a:r>
-          </a:p>
-          <a:p>
-            <a:r>
-              <a:t>Navigation/resource slides support these scheduled steps and do not add instructional time.</a:t>
-            </a:r>
-          </a:p>
-          <a:p>
-            <a:r>
-              <a:t>SLIDE PLACEMENT: Recall, 10:35 AM–10:40 AM. All slides with this phase share these 5 minutes; do not restart the time allocation for each slide.</a:t>
+              <a:t>Keep activities within the allocated phase time.</a:t>
+            </a:r>
+          </a:p>
+          <a:p>
+            <a:r>
+              <a:t>PHASE TIMING: Recall, 10:35 AM–10:40 AM. All slides with this phase share these 5 minutes; do not restart the time allocation for each slide.</a:t>
             </a:r>
           </a:p>
         </p:txBody>
@@ -8688,11 +7678,6 @@
               <a:t>Materials/check: Notebook; calculator</a:t>
             </a:r>
           </a:p>
-          <a:p>
-            <a:r>
-              <a:t>Source: 'Math Week 1'!A42:F42</a:t>
-            </a:r>
-          </a:p>
           <a:p/>
           <a:p>
             <a:r>
@@ -8714,11 +7699,6 @@
               <a:t>Materials/check: Identify support needs</a:t>
             </a:r>
           </a:p>
-          <a:p>
-            <a:r>
-              <a:t>Source: 'Math Week 1'!A43:F43</a:t>
-            </a:r>
-          </a:p>
           <a:p/>
           <a:p>
             <a:r>
@@ -8740,11 +7720,6 @@
               <a:t>Materials/check: Textbook; worked example</a:t>
             </a:r>
           </a:p>
-          <a:p>
-            <a:r>
-              <a:t>Source: 'Math Week 1'!A44:F44</a:t>
-            </a:r>
-          </a:p>
           <a:p/>
           <a:p>
             <a:r>
@@ -8766,11 +7741,6 @@
               <a:t>Materials/check: Exercise Book; tool above</a:t>
             </a:r>
           </a:p>
-          <a:p>
-            <a:r>
-              <a:t>Source: 'Math Week 1'!A45:F45</a:t>
-            </a:r>
-          </a:p>
           <a:p/>
           <a:p>
             <a:r>
@@ -8792,11 +7762,6 @@
               <a:t>Materials/check: Paper first; tool second</a:t>
             </a:r>
           </a:p>
-          <a:p>
-            <a:r>
-              <a:t>Source: 'Math Week 1'!A46:F46</a:t>
-            </a:r>
-          </a:p>
           <a:p/>
           <a:p>
             <a:r>
@@ -8818,11 +7783,6 @@
               <a:t>Materials/check: Teacher answers below</a:t>
             </a:r>
           </a:p>
-          <a:p>
-            <a:r>
-              <a:t>Source: 'Math Week 1'!A47:F47</a:t>
-            </a:r>
-          </a:p>
           <a:p/>
           <a:p>
             <a:r>
@@ -8844,11 +7804,6 @@
               <a:t>Materials/check: Notebook / error log</a:t>
             </a:r>
           </a:p>
-          <a:p>
-            <a:r>
-              <a:t>Source: 'Math Week 1'!A48:F48</a:t>
-            </a:r>
-          </a:p>
           <a:p/>
           <a:p>
             <a:r>
@@ -8869,48 +7824,23 @@
           <a:p/>
           <a:p>
             <a:r>
-              <a:t>Sources: 'Math Week 1'!A11:E11; 'Carpentry Schedule'!E5; 'Math Week 1'!A36</a:t>
-            </a:r>
-          </a:p>
-          <a:p>
-            <a:r>
-              <a:t>Navigation/resource slides support these scheduled steps and do not add instructional time.</a:t>
-            </a:r>
-          </a:p>
-          <a:p>
-            <a:r>
-              <a:t>SLIDE PLACEMENT: Teach, 10:40 AM–10:55 AM. All slides with this phase share these 15 minutes; do not restart the time allocation for each slide.</a:t>
-            </a:r>
-          </a:p>
-          <a:p/>
-          <a:p>
-            <a:r>
-              <a:t>Teaching content sources:</a:t>
-            </a:r>
-          </a:p>
-          <a:p>
-            <a:r>
-              <a:t>'Math Week 1'!A36</a:t>
-            </a:r>
-          </a:p>
-          <a:p>
-            <a:r>
-              <a:t>'Math Week 1'!B38</a:t>
-            </a:r>
-          </a:p>
-          <a:p>
-            <a:r>
-              <a:t>'Math Week 1'!B40</a:t>
+              <a:t>Keep activities within the allocated phase time.</a:t>
+            </a:r>
+          </a:p>
+          <a:p>
+            <a:r>
+              <a:t>PHASE TIMING: Teach, 10:40 AM–10:55 AM. All slides with this phase share these 15 minutes; do not restart the time allocation for each slide.</a:t>
+            </a:r>
+          </a:p>
+          <a:p/>
+          <a:p>
+            <a:r>
+              <a:t>Teaching references:</a:t>
             </a:r>
           </a:p>
           <a:p>
             <a:r>
               <a:t>Textbook Chapter 2 pp.28–33,39; Chapter 1 pp.12–21</a:t>
-            </a:r>
-          </a:p>
-          <a:p>
-            <a:r>
-              <a:t>ACCESS CARPENTRY SLIDES.pptx slides 6–8</a:t>
             </a:r>
           </a:p>
           <a:p>
@@ -9044,11 +7974,6 @@
               <a:t>Materials/check: Notebook; calculator</a:t>
             </a:r>
           </a:p>
-          <a:p>
-            <a:r>
-              <a:t>Source: 'Math Week 1'!A42:F42</a:t>
-            </a:r>
-          </a:p>
           <a:p/>
           <a:p>
             <a:r>
@@ -9070,11 +7995,6 @@
               <a:t>Materials/check: Identify support needs</a:t>
             </a:r>
           </a:p>
-          <a:p>
-            <a:r>
-              <a:t>Source: 'Math Week 1'!A43:F43</a:t>
-            </a:r>
-          </a:p>
           <a:p/>
           <a:p>
             <a:r>
@@ -9096,11 +8016,6 @@
               <a:t>Materials/check: Textbook; worked example</a:t>
             </a:r>
           </a:p>
-          <a:p>
-            <a:r>
-              <a:t>Source: 'Math Week 1'!A44:F44</a:t>
-            </a:r>
-          </a:p>
           <a:p/>
           <a:p>
             <a:r>
@@ -9122,11 +8037,6 @@
               <a:t>Materials/check: Exercise Book; tool above</a:t>
             </a:r>
           </a:p>
-          <a:p>
-            <a:r>
-              <a:t>Source: 'Math Week 1'!A45:F45</a:t>
-            </a:r>
-          </a:p>
           <a:p/>
           <a:p>
             <a:r>
@@ -9148,11 +8058,6 @@
               <a:t>Materials/check: Paper first; tool second</a:t>
             </a:r>
           </a:p>
-          <a:p>
-            <a:r>
-              <a:t>Source: 'Math Week 1'!A46:F46</a:t>
-            </a:r>
-          </a:p>
           <a:p/>
           <a:p>
             <a:r>
@@ -9174,11 +8079,6 @@
               <a:t>Materials/check: Teacher answers below</a:t>
             </a:r>
           </a:p>
-          <a:p>
-            <a:r>
-              <a:t>Source: 'Math Week 1'!A47:F47</a:t>
-            </a:r>
-          </a:p>
           <a:p/>
           <a:p>
             <a:r>
@@ -9200,11 +8100,6 @@
               <a:t>Materials/check: Notebook / error log</a:t>
             </a:r>
           </a:p>
-          <a:p>
-            <a:r>
-              <a:t>Source: 'Math Week 1'!A48:F48</a:t>
-            </a:r>
-          </a:p>
           <a:p/>
           <a:p>
             <a:r>
@@ -9225,48 +8120,23 @@
           <a:p/>
           <a:p>
             <a:r>
-              <a:t>Sources: 'Math Week 1'!A11:E11; 'Carpentry Schedule'!E5; 'Math Week 1'!A36</a:t>
-            </a:r>
-          </a:p>
-          <a:p>
-            <a:r>
-              <a:t>Navigation/resource slides support these scheduled steps and do not add instructional time.</a:t>
-            </a:r>
-          </a:p>
-          <a:p>
-            <a:r>
-              <a:t>SLIDE PLACEMENT: Teach, 10:40 AM–10:55 AM. All slides with this phase share these 15 minutes; do not restart the time allocation for each slide.</a:t>
-            </a:r>
-          </a:p>
-          <a:p/>
-          <a:p>
-            <a:r>
-              <a:t>Teaching content sources:</a:t>
-            </a:r>
-          </a:p>
-          <a:p>
-            <a:r>
-              <a:t>'Math Week 1'!A36</a:t>
-            </a:r>
-          </a:p>
-          <a:p>
-            <a:r>
-              <a:t>'Math Week 1'!B38</a:t>
-            </a:r>
-          </a:p>
-          <a:p>
-            <a:r>
-              <a:t>'Math Week 1'!B40</a:t>
+              <a:t>Keep activities within the allocated phase time.</a:t>
+            </a:r>
+          </a:p>
+          <a:p>
+            <a:r>
+              <a:t>PHASE TIMING: Teach, 10:40 AM–10:55 AM. All slides with this phase share these 15 minutes; do not restart the time allocation for each slide.</a:t>
+            </a:r>
+          </a:p>
+          <a:p/>
+          <a:p>
+            <a:r>
+              <a:t>Teaching references:</a:t>
             </a:r>
           </a:p>
           <a:p>
             <a:r>
               <a:t>Textbook Chapter 2 pp.28–33,39; Chapter 1 pp.12–21</a:t>
-            </a:r>
-          </a:p>
-          <a:p>
-            <a:r>
-              <a:t>ACCESS CARPENTRY SLIDES.pptx slides 6–8</a:t>
             </a:r>
           </a:p>
           <a:p>
@@ -9400,11 +8270,6 @@
               <a:t>Materials/check: Notebook; calculator</a:t>
             </a:r>
           </a:p>
-          <a:p>
-            <a:r>
-              <a:t>Source: 'Math Week 1'!A42:F42</a:t>
-            </a:r>
-          </a:p>
           <a:p/>
           <a:p>
             <a:r>
@@ -9426,11 +8291,6 @@
               <a:t>Materials/check: Identify support needs</a:t>
             </a:r>
           </a:p>
-          <a:p>
-            <a:r>
-              <a:t>Source: 'Math Week 1'!A43:F43</a:t>
-            </a:r>
-          </a:p>
           <a:p/>
           <a:p>
             <a:r>
@@ -9452,11 +8312,6 @@
               <a:t>Materials/check: Textbook; worked example</a:t>
             </a:r>
           </a:p>
-          <a:p>
-            <a:r>
-              <a:t>Source: 'Math Week 1'!A44:F44</a:t>
-            </a:r>
-          </a:p>
           <a:p/>
           <a:p>
             <a:r>
@@ -9478,11 +8333,6 @@
               <a:t>Materials/check: Exercise Book; tool above</a:t>
             </a:r>
           </a:p>
-          <a:p>
-            <a:r>
-              <a:t>Source: 'Math Week 1'!A45:F45</a:t>
-            </a:r>
-          </a:p>
           <a:p/>
           <a:p>
             <a:r>
@@ -9504,11 +8354,6 @@
               <a:t>Materials/check: Paper first; tool second</a:t>
             </a:r>
           </a:p>
-          <a:p>
-            <a:r>
-              <a:t>Source: 'Math Week 1'!A46:F46</a:t>
-            </a:r>
-          </a:p>
           <a:p/>
           <a:p>
             <a:r>
@@ -9530,11 +8375,6 @@
               <a:t>Materials/check: Teacher answers below</a:t>
             </a:r>
           </a:p>
-          <a:p>
-            <a:r>
-              <a:t>Source: 'Math Week 1'!A47:F47</a:t>
-            </a:r>
-          </a:p>
           <a:p/>
           <a:p>
             <a:r>
@@ -9556,11 +8396,6 @@
               <a:t>Materials/check: Notebook / error log</a:t>
             </a:r>
           </a:p>
-          <a:p>
-            <a:r>
-              <a:t>Source: 'Math Week 1'!A48:F48</a:t>
-            </a:r>
-          </a:p>
           <a:p/>
           <a:p>
             <a:r>
@@ -9581,17 +8416,12 @@
           <a:p/>
           <a:p>
             <a:r>
-              <a:t>Sources: 'Math Week 1'!A11:E11; 'Carpentry Schedule'!E5; 'Math Week 1'!A36</a:t>
-            </a:r>
-          </a:p>
-          <a:p>
-            <a:r>
-              <a:t>Navigation/resource slides support these scheduled steps and do not add instructional time.</a:t>
-            </a:r>
-          </a:p>
-          <a:p>
-            <a:r>
-              <a:t>SLIDE PLACEMENT: Teach, 10:40 AM–10:55 AM. All slides with this phase share these 15 minutes; do not restart the time allocation for each slide.</a:t>
+              <a:t>Keep activities within the allocated phase time.</a:t>
+            </a:r>
+          </a:p>
+          <a:p>
+            <a:r>
+              <a:t>PHASE TIMING: Teach, 10:40 AM–10:55 AM. All slides with this phase share these 15 minutes; do not restart the time allocation for each slide.</a:t>
             </a:r>
           </a:p>
           <a:p/>
@@ -9602,7 +8432,7 @@
           </a:p>
           <a:p>
             <a:r>
-              <a:t>Exact PDF/printed page: 29. Excerpt reproduced from the supplied ACCESS Textbook.</a:t>
+              <a:t>Exact PDF/printed page: 29. ACCESS Textbook excerpt.</a:t>
             </a:r>
           </a:p>
           <a:p>
@@ -9736,11 +8566,6 @@
               <a:t>Materials/check: Notebook; calculator</a:t>
             </a:r>
           </a:p>
-          <a:p>
-            <a:r>
-              <a:t>Source: 'Math Week 1'!A42:F42</a:t>
-            </a:r>
-          </a:p>
           <a:p/>
           <a:p>
             <a:r>
@@ -9762,11 +8587,6 @@
               <a:t>Materials/check: Identify support needs</a:t>
             </a:r>
           </a:p>
-          <a:p>
-            <a:r>
-              <a:t>Source: 'Math Week 1'!A43:F43</a:t>
-            </a:r>
-          </a:p>
           <a:p/>
           <a:p>
             <a:r>
@@ -9788,11 +8608,6 @@
               <a:t>Materials/check: Textbook; worked example</a:t>
             </a:r>
           </a:p>
-          <a:p>
-            <a:r>
-              <a:t>Source: 'Math Week 1'!A44:F44</a:t>
-            </a:r>
-          </a:p>
           <a:p/>
           <a:p>
             <a:r>
@@ -9814,11 +8629,6 @@
               <a:t>Materials/check: Exercise Book; tool above</a:t>
             </a:r>
           </a:p>
-          <a:p>
-            <a:r>
-              <a:t>Source: 'Math Week 1'!A45:F45</a:t>
-            </a:r>
-          </a:p>
           <a:p/>
           <a:p>
             <a:r>
@@ -9840,11 +8650,6 @@
               <a:t>Materials/check: Paper first; tool second</a:t>
             </a:r>
           </a:p>
-          <a:p>
-            <a:r>
-              <a:t>Source: 'Math Week 1'!A46:F46</a:t>
-            </a:r>
-          </a:p>
           <a:p/>
           <a:p>
             <a:r>
@@ -9866,11 +8671,6 @@
               <a:t>Materials/check: Teacher answers below</a:t>
             </a:r>
           </a:p>
-          <a:p>
-            <a:r>
-              <a:t>Source: 'Math Week 1'!A47:F47</a:t>
-            </a:r>
-          </a:p>
           <a:p/>
           <a:p>
             <a:r>
@@ -9892,11 +8692,6 @@
               <a:t>Materials/check: Notebook / error log</a:t>
             </a:r>
           </a:p>
-          <a:p>
-            <a:r>
-              <a:t>Source: 'Math Week 1'!A48:F48</a:t>
-            </a:r>
-          </a:p>
           <a:p/>
           <a:p>
             <a:r>
@@ -9917,17 +8712,12 @@
           <a:p/>
           <a:p>
             <a:r>
-              <a:t>Sources: 'Math Week 1'!A11:E11; 'Carpentry Schedule'!E5; 'Math Week 1'!A36</a:t>
-            </a:r>
-          </a:p>
-          <a:p>
-            <a:r>
-              <a:t>Navigation/resource slides support these scheduled steps and do not add instructional time.</a:t>
-            </a:r>
-          </a:p>
-          <a:p>
-            <a:r>
-              <a:t>SLIDE PLACEMENT: Teach, 10:40 AM–10:55 AM. All slides with this phase share these 15 minutes; do not restart the time allocation for each slide.</a:t>
+              <a:t>Keep activities within the allocated phase time.</a:t>
+            </a:r>
+          </a:p>
+          <a:p>
+            <a:r>
+              <a:t>PHASE TIMING: Teach, 10:40 AM–10:55 AM. All slides with this phase share these 15 minutes; do not restart the time allocation for each slide.</a:t>
             </a:r>
           </a:p>
           <a:p/>
@@ -9938,7 +8728,7 @@
           </a:p>
           <a:p>
             <a:r>
-              <a:t>Exact PDF/printed page: 32. Excerpt reproduced from the supplied ACCESS Textbook.</a:t>
+              <a:t>Exact PDF/printed page: 32. ACCESS Textbook excerpt.</a:t>
             </a:r>
           </a:p>
           <a:p>
@@ -10072,11 +8862,6 @@
               <a:t>Materials/check: Notebook; calculator</a:t>
             </a:r>
           </a:p>
-          <a:p>
-            <a:r>
-              <a:t>Source: 'Math Week 1'!A42:F42</a:t>
-            </a:r>
-          </a:p>
           <a:p/>
           <a:p>
             <a:r>
@@ -10098,11 +8883,6 @@
               <a:t>Materials/check: Identify support needs</a:t>
             </a:r>
           </a:p>
-          <a:p>
-            <a:r>
-              <a:t>Source: 'Math Week 1'!A43:F43</a:t>
-            </a:r>
-          </a:p>
           <a:p/>
           <a:p>
             <a:r>
@@ -10124,11 +8904,6 @@
               <a:t>Materials/check: Textbook; worked example</a:t>
             </a:r>
           </a:p>
-          <a:p>
-            <a:r>
-              <a:t>Source: 'Math Week 1'!A44:F44</a:t>
-            </a:r>
-          </a:p>
           <a:p/>
           <a:p>
             <a:r>
@@ -10150,11 +8925,6 @@
               <a:t>Materials/check: Exercise Book; tool above</a:t>
             </a:r>
           </a:p>
-          <a:p>
-            <a:r>
-              <a:t>Source: 'Math Week 1'!A45:F45</a:t>
-            </a:r>
-          </a:p>
           <a:p/>
           <a:p>
             <a:r>
@@ -10176,11 +8946,6 @@
               <a:t>Materials/check: Paper first; tool second</a:t>
             </a:r>
           </a:p>
-          <a:p>
-            <a:r>
-              <a:t>Source: 'Math Week 1'!A46:F46</a:t>
-            </a:r>
-          </a:p>
           <a:p/>
           <a:p>
             <a:r>
@@ -10202,11 +8967,6 @@
               <a:t>Materials/check: Teacher answers below</a:t>
             </a:r>
           </a:p>
-          <a:p>
-            <a:r>
-              <a:t>Source: 'Math Week 1'!A47:F47</a:t>
-            </a:r>
-          </a:p>
           <a:p/>
           <a:p>
             <a:r>
@@ -10228,11 +8988,6 @@
               <a:t>Materials/check: Notebook / error log</a:t>
             </a:r>
           </a:p>
-          <a:p>
-            <a:r>
-              <a:t>Source: 'Math Week 1'!A48:F48</a:t>
-            </a:r>
-          </a:p>
           <a:p/>
           <a:p>
             <a:r>
@@ -10253,17 +9008,12 @@
           <a:p/>
           <a:p>
             <a:r>
-              <a:t>Sources: 'Math Week 1'!A11:E11; 'Carpentry Schedule'!E5; 'Math Week 1'!A36</a:t>
-            </a:r>
-          </a:p>
-          <a:p>
-            <a:r>
-              <a:t>Navigation/resource slides support these scheduled steps and do not add instructional time.</a:t>
-            </a:r>
-          </a:p>
-          <a:p>
-            <a:r>
-              <a:t>SLIDE PLACEMENT: Teach, 10:40 AM–10:55 AM. All slides with this phase share these 15 minutes; do not restart the time allocation for each slide.</a:t>
+              <a:t>Keep activities within the allocated phase time.</a:t>
+            </a:r>
+          </a:p>
+          <a:p>
+            <a:r>
+              <a:t>PHASE TIMING: Teach, 10:40 AM–10:55 AM. All slides with this phase share these 15 minutes; do not restart the time allocation for each slide.</a:t>
             </a:r>
           </a:p>
           <a:p/>
@@ -10398,11 +9148,6 @@
               <a:t>Materials/check: Notebook; calculator</a:t>
             </a:r>
           </a:p>
-          <a:p>
-            <a:r>
-              <a:t>Source: 'Math Week 1'!A42:F42</a:t>
-            </a:r>
-          </a:p>
           <a:p/>
           <a:p>
             <a:r>
@@ -10424,11 +9169,6 @@
               <a:t>Materials/check: Identify support needs</a:t>
             </a:r>
           </a:p>
-          <a:p>
-            <a:r>
-              <a:t>Source: 'Math Week 1'!A43:F43</a:t>
-            </a:r>
-          </a:p>
           <a:p/>
           <a:p>
             <a:r>
@@ -10450,11 +9190,6 @@
               <a:t>Materials/check: Textbook; worked example</a:t>
             </a:r>
           </a:p>
-          <a:p>
-            <a:r>
-              <a:t>Source: 'Math Week 1'!A44:F44</a:t>
-            </a:r>
-          </a:p>
           <a:p/>
           <a:p>
             <a:r>
@@ -10476,11 +9211,6 @@
               <a:t>Materials/check: Exercise Book; tool above</a:t>
             </a:r>
           </a:p>
-          <a:p>
-            <a:r>
-              <a:t>Source: 'Math Week 1'!A45:F45</a:t>
-            </a:r>
-          </a:p>
           <a:p/>
           <a:p>
             <a:r>
@@ -10502,11 +9232,6 @@
               <a:t>Materials/check: Paper first; tool second</a:t>
             </a:r>
           </a:p>
-          <a:p>
-            <a:r>
-              <a:t>Source: 'Math Week 1'!A46:F46</a:t>
-            </a:r>
-          </a:p>
           <a:p/>
           <a:p>
             <a:r>
@@ -10528,11 +9253,6 @@
               <a:t>Materials/check: Teacher answers below</a:t>
             </a:r>
           </a:p>
-          <a:p>
-            <a:r>
-              <a:t>Source: 'Math Week 1'!A47:F47</a:t>
-            </a:r>
-          </a:p>
           <a:p/>
           <a:p>
             <a:r>
@@ -10554,11 +9274,6 @@
               <a:t>Materials/check: Notebook / error log</a:t>
             </a:r>
           </a:p>
-          <a:p>
-            <a:r>
-              <a:t>Source: 'Math Week 1'!A48:F48</a:t>
-            </a:r>
-          </a:p>
           <a:p/>
           <a:p>
             <a:r>
@@ -10579,17 +9294,12 @@
           <a:p/>
           <a:p>
             <a:r>
-              <a:t>Sources: 'Math Week 1'!A11:E11; 'Carpentry Schedule'!E5; 'Math Week 1'!A36</a:t>
-            </a:r>
-          </a:p>
-          <a:p>
-            <a:r>
-              <a:t>Navigation/resource slides support these scheduled steps and do not add instructional time.</a:t>
-            </a:r>
-          </a:p>
-          <a:p>
-            <a:r>
-              <a:t>SLIDE PLACEMENT: Together, 10:55 AM–11:10 AM. All slides with this phase share these 15 minutes; do not restart the time allocation for each slide.</a:t>
+              <a:t>Keep activities within the allocated phase time.</a:t>
+            </a:r>
+          </a:p>
+          <a:p>
+            <a:r>
+              <a:t>PHASE TIMING: Together, 10:55 AM–11:10 AM. All slides with this phase share these 15 minutes; do not restart the time allocation for each slide.</a:t>
             </a:r>
           </a:p>
         </p:txBody>
@@ -10718,11 +9428,6 @@
               <a:t>Materials/check: Notebook; calculator</a:t>
             </a:r>
           </a:p>
-          <a:p>
-            <a:r>
-              <a:t>Source: 'Math Week 1'!A42:F42</a:t>
-            </a:r>
-          </a:p>
           <a:p/>
           <a:p>
             <a:r>
@@ -10744,11 +9449,6 @@
               <a:t>Materials/check: Identify support needs</a:t>
             </a:r>
           </a:p>
-          <a:p>
-            <a:r>
-              <a:t>Source: 'Math Week 1'!A43:F43</a:t>
-            </a:r>
-          </a:p>
           <a:p/>
           <a:p>
             <a:r>
@@ -10770,11 +9470,6 @@
               <a:t>Materials/check: Textbook; worked example</a:t>
             </a:r>
           </a:p>
-          <a:p>
-            <a:r>
-              <a:t>Source: 'Math Week 1'!A44:F44</a:t>
-            </a:r>
-          </a:p>
           <a:p/>
           <a:p>
             <a:r>
@@ -10796,11 +9491,6 @@
               <a:t>Materials/check: Exercise Book; tool above</a:t>
             </a:r>
           </a:p>
-          <a:p>
-            <a:r>
-              <a:t>Source: 'Math Week 1'!A45:F45</a:t>
-            </a:r>
-          </a:p>
           <a:p/>
           <a:p>
             <a:r>
@@ -10822,11 +9512,6 @@
               <a:t>Materials/check: Paper first; tool second</a:t>
             </a:r>
           </a:p>
-          <a:p>
-            <a:r>
-              <a:t>Source: 'Math Week 1'!A46:F46</a:t>
-            </a:r>
-          </a:p>
           <a:p/>
           <a:p>
             <a:r>
@@ -10848,11 +9533,6 @@
               <a:t>Materials/check: Teacher answers below</a:t>
             </a:r>
           </a:p>
-          <a:p>
-            <a:r>
-              <a:t>Source: 'Math Week 1'!A47:F47</a:t>
-            </a:r>
-          </a:p>
           <a:p/>
           <a:p>
             <a:r>
@@ -10874,11 +9554,6 @@
               <a:t>Materials/check: Notebook / error log</a:t>
             </a:r>
           </a:p>
-          <a:p>
-            <a:r>
-              <a:t>Source: 'Math Week 1'!A48:F48</a:t>
-            </a:r>
-          </a:p>
           <a:p/>
           <a:p>
             <a:r>
@@ -10899,17 +9574,12 @@
           <a:p/>
           <a:p>
             <a:r>
-              <a:t>Sources: 'Math Week 1'!A11:E11; 'Carpentry Schedule'!E5; 'Math Week 1'!A36</a:t>
-            </a:r>
-          </a:p>
-          <a:p>
-            <a:r>
-              <a:t>Navigation/resource slides support these scheduled steps and do not add instructional time.</a:t>
-            </a:r>
-          </a:p>
-          <a:p>
-            <a:r>
-              <a:t>SLIDE PLACEMENT: Together, 10:55 AM–11:10 AM. All slides with this phase share these 15 minutes; do not restart the time allocation for each slide.</a:t>
+              <a:t>Keep activities within the allocated phase time.</a:t>
+            </a:r>
+          </a:p>
+          <a:p>
+            <a:r>
+              <a:t>PHASE TIMING: Together, 10:55 AM–11:10 AM. All slides with this phase share these 15 minutes; do not restart the time allocation for each slide.</a:t>
             </a:r>
           </a:p>
           <a:p/>
@@ -11064,11 +9734,6 @@
               <a:t>Materials/check: Notebook; calculator</a:t>
             </a:r>
           </a:p>
-          <a:p>
-            <a:r>
-              <a:t>Source: 'Math Week 1'!A42:F42</a:t>
-            </a:r>
-          </a:p>
           <a:p/>
           <a:p>
             <a:r>
@@ -11090,11 +9755,6 @@
               <a:t>Materials/check: Identify support needs</a:t>
             </a:r>
           </a:p>
-          <a:p>
-            <a:r>
-              <a:t>Source: 'Math Week 1'!A43:F43</a:t>
-            </a:r>
-          </a:p>
           <a:p/>
           <a:p>
             <a:r>
@@ -11116,11 +9776,6 @@
               <a:t>Materials/check: Textbook; worked example</a:t>
             </a:r>
           </a:p>
-          <a:p>
-            <a:r>
-              <a:t>Source: 'Math Week 1'!A44:F44</a:t>
-            </a:r>
-          </a:p>
           <a:p/>
           <a:p>
             <a:r>
@@ -11142,11 +9797,6 @@
               <a:t>Materials/check: Exercise Book; tool above</a:t>
             </a:r>
           </a:p>
-          <a:p>
-            <a:r>
-              <a:t>Source: 'Math Week 1'!A45:F45</a:t>
-            </a:r>
-          </a:p>
           <a:p/>
           <a:p>
             <a:r>
@@ -11168,11 +9818,6 @@
               <a:t>Materials/check: Paper first; tool second</a:t>
             </a:r>
           </a:p>
-          <a:p>
-            <a:r>
-              <a:t>Source: 'Math Week 1'!A46:F46</a:t>
-            </a:r>
-          </a:p>
           <a:p/>
           <a:p>
             <a:r>
@@ -11194,11 +9839,6 @@
               <a:t>Materials/check: Teacher answers below</a:t>
             </a:r>
           </a:p>
-          <a:p>
-            <a:r>
-              <a:t>Source: 'Math Week 1'!A47:F47</a:t>
-            </a:r>
-          </a:p>
           <a:p/>
           <a:p>
             <a:r>
@@ -11220,11 +9860,6 @@
               <a:t>Materials/check: Notebook / error log</a:t>
             </a:r>
           </a:p>
-          <a:p>
-            <a:r>
-              <a:t>Source: 'Math Week 1'!A48:F48</a:t>
-            </a:r>
-          </a:p>
           <a:p/>
           <a:p>
             <a:r>
@@ -11245,17 +9880,12 @@
           <a:p/>
           <a:p>
             <a:r>
-              <a:t>Sources: 'Math Week 1'!A11:E11; 'Carpentry Schedule'!E5; 'Math Week 1'!A36</a:t>
-            </a:r>
-          </a:p>
-          <a:p>
-            <a:r>
-              <a:t>Navigation/resource slides support these scheduled steps and do not add instructional time.</a:t>
-            </a:r>
-          </a:p>
-          <a:p>
-            <a:r>
-              <a:t>SLIDE PLACEMENT: Together, 10:55 AM–11:10 AM. All slides with this phase share these 15 minutes; do not restart the time allocation for each slide.</a:t>
+              <a:t>Keep activities within the allocated phase time.</a:t>
+            </a:r>
+          </a:p>
+          <a:p>
+            <a:r>
+              <a:t>PHASE TIMING: Together, 10:55 AM–11:10 AM. All slides with this phase share these 15 minutes; do not restart the time allocation for each slide.</a:t>
             </a:r>
           </a:p>
           <a:p/>
@@ -11410,11 +10040,6 @@
               <a:t>Materials/check: Notebook; calculator</a:t>
             </a:r>
           </a:p>
-          <a:p>
-            <a:r>
-              <a:t>Source: 'Math Week 1'!A42:F42</a:t>
-            </a:r>
-          </a:p>
           <a:p/>
           <a:p>
             <a:r>
@@ -11436,11 +10061,6 @@
               <a:t>Materials/check: Identify support needs</a:t>
             </a:r>
           </a:p>
-          <a:p>
-            <a:r>
-              <a:t>Source: 'Math Week 1'!A43:F43</a:t>
-            </a:r>
-          </a:p>
           <a:p/>
           <a:p>
             <a:r>
@@ -11462,11 +10082,6 @@
               <a:t>Materials/check: Textbook; worked example</a:t>
             </a:r>
           </a:p>
-          <a:p>
-            <a:r>
-              <a:t>Source: 'Math Week 1'!A44:F44</a:t>
-            </a:r>
-          </a:p>
           <a:p/>
           <a:p>
             <a:r>
@@ -11488,11 +10103,6 @@
               <a:t>Materials/check: Exercise Book; tool above</a:t>
             </a:r>
           </a:p>
-          <a:p>
-            <a:r>
-              <a:t>Source: 'Math Week 1'!A45:F45</a:t>
-            </a:r>
-          </a:p>
           <a:p/>
           <a:p>
             <a:r>
@@ -11514,11 +10124,6 @@
               <a:t>Materials/check: Paper first; tool second</a:t>
             </a:r>
           </a:p>
-          <a:p>
-            <a:r>
-              <a:t>Source: 'Math Week 1'!A46:F46</a:t>
-            </a:r>
-          </a:p>
           <a:p/>
           <a:p>
             <a:r>
@@ -11540,11 +10145,6 @@
               <a:t>Materials/check: Teacher answers below</a:t>
             </a:r>
           </a:p>
-          <a:p>
-            <a:r>
-              <a:t>Source: 'Math Week 1'!A47:F47</a:t>
-            </a:r>
-          </a:p>
           <a:p/>
           <a:p>
             <a:r>
@@ -11566,11 +10166,6 @@
               <a:t>Materials/check: Notebook / error log</a:t>
             </a:r>
           </a:p>
-          <a:p>
-            <a:r>
-              <a:t>Source: 'Math Week 1'!A48:F48</a:t>
-            </a:r>
-          </a:p>
           <a:p/>
           <a:p>
             <a:r>
@@ -11591,17 +10186,12 @@
           <a:p/>
           <a:p>
             <a:r>
-              <a:t>Sources: 'Math Week 1'!A11:E11; 'Carpentry Schedule'!E5; 'Math Week 1'!A36</a:t>
-            </a:r>
-          </a:p>
-          <a:p>
-            <a:r>
-              <a:t>Navigation/resource slides support these scheduled steps and do not add instructional time.</a:t>
-            </a:r>
-          </a:p>
-          <a:p>
-            <a:r>
-              <a:t>SLIDE PLACEMENT: Practise, 11:10 AM–11:45 AM. All slides with this phase share these 35 minutes; do not restart the time allocation for each slide.</a:t>
+              <a:t>Keep activities within the allocated phase time.</a:t>
+            </a:r>
+          </a:p>
+          <a:p>
+            <a:r>
+              <a:t>PHASE TIMING: Practise, 11:10 AM–11:45 AM. All slides with this phase share these 35 minutes; do not restart the time allocation for each slide.</a:t>
             </a:r>
           </a:p>
         </p:txBody>
@@ -11730,11 +10320,6 @@
               <a:t>Materials/check: Notebook; calculator</a:t>
             </a:r>
           </a:p>
-          <a:p>
-            <a:r>
-              <a:t>Source: 'Math Week 1'!A42:F42</a:t>
-            </a:r>
-          </a:p>
           <a:p/>
           <a:p>
             <a:r>
@@ -11756,11 +10341,6 @@
               <a:t>Materials/check: Identify support needs</a:t>
             </a:r>
           </a:p>
-          <a:p>
-            <a:r>
-              <a:t>Source: 'Math Week 1'!A43:F43</a:t>
-            </a:r>
-          </a:p>
           <a:p/>
           <a:p>
             <a:r>
@@ -11782,11 +10362,6 @@
               <a:t>Materials/check: Textbook; worked example</a:t>
             </a:r>
           </a:p>
-          <a:p>
-            <a:r>
-              <a:t>Source: 'Math Week 1'!A44:F44</a:t>
-            </a:r>
-          </a:p>
           <a:p/>
           <a:p>
             <a:r>
@@ -11808,11 +10383,6 @@
               <a:t>Materials/check: Exercise Book; tool above</a:t>
             </a:r>
           </a:p>
-          <a:p>
-            <a:r>
-              <a:t>Source: 'Math Week 1'!A45:F45</a:t>
-            </a:r>
-          </a:p>
           <a:p/>
           <a:p>
             <a:r>
@@ -11834,11 +10404,6 @@
               <a:t>Materials/check: Paper first; tool second</a:t>
             </a:r>
           </a:p>
-          <a:p>
-            <a:r>
-              <a:t>Source: 'Math Week 1'!A46:F46</a:t>
-            </a:r>
-          </a:p>
           <a:p/>
           <a:p>
             <a:r>
@@ -11860,11 +10425,6 @@
               <a:t>Materials/check: Teacher answers below</a:t>
             </a:r>
           </a:p>
-          <a:p>
-            <a:r>
-              <a:t>Source: 'Math Week 1'!A47:F47</a:t>
-            </a:r>
-          </a:p>
           <a:p/>
           <a:p>
             <a:r>
@@ -11886,11 +10446,6 @@
               <a:t>Materials/check: Notebook / error log</a:t>
             </a:r>
           </a:p>
-          <a:p>
-            <a:r>
-              <a:t>Source: 'Math Week 1'!A48:F48</a:t>
-            </a:r>
-          </a:p>
           <a:p/>
           <a:p>
             <a:r>
@@ -11911,23 +10466,18 @@
           <a:p/>
           <a:p>
             <a:r>
-              <a:t>Sources: 'Math Week 1'!A11:E11; 'Carpentry Schedule'!E5; 'Math Week 1'!A36</a:t>
-            </a:r>
-          </a:p>
-          <a:p>
-            <a:r>
-              <a:t>Navigation/resource slides support these scheduled steps and do not add instructional time.</a:t>
-            </a:r>
-          </a:p>
-          <a:p>
-            <a:r>
-              <a:t>SLIDE PLACEMENT: Practise, 11:10 AM–11:45 AM. All slides with this phase share these 35 minutes; do not restart the time allocation for each slide.</a:t>
-            </a:r>
-          </a:p>
-          <a:p/>
-          <a:p>
-            <a:r>
-              <a:t>Live-tool screenshot, not an answer to the scheduled task. Open the resource link and follow the exact values in the assignment. Keep worked answers hidden until learners attempt the task. Screenshot illustrates navigation and occupies time within the same scheduled practice phase.</a:t>
+              <a:t>Keep activities within the allocated phase time.</a:t>
+            </a:r>
+          </a:p>
+          <a:p>
+            <a:r>
+              <a:t>PHASE TIMING: Practise, 11:10 AM–11:45 AM. All slides with this phase share these 35 minutes; do not restart the time allocation for each slide.</a:t>
+            </a:r>
+          </a:p>
+          <a:p/>
+          <a:p>
+            <a:r>
+              <a:t>Demonstrate navigation, then open the tool and use the assigned values. Keep worked answers hidden until learners attempt the task. Include this activity within the allocated practice time.</a:t>
             </a:r>
           </a:p>
         </p:txBody>
@@ -12056,11 +10606,6 @@
               <a:t>Materials/check: Notebook; calculator</a:t>
             </a:r>
           </a:p>
-          <a:p>
-            <a:r>
-              <a:t>Source: 'Math Week 1'!A42:F42</a:t>
-            </a:r>
-          </a:p>
           <a:p/>
           <a:p>
             <a:r>
@@ -12082,11 +10627,6 @@
               <a:t>Materials/check: Identify support needs</a:t>
             </a:r>
           </a:p>
-          <a:p>
-            <a:r>
-              <a:t>Source: 'Math Week 1'!A43:F43</a:t>
-            </a:r>
-          </a:p>
           <a:p/>
           <a:p>
             <a:r>
@@ -12108,11 +10648,6 @@
               <a:t>Materials/check: Textbook; worked example</a:t>
             </a:r>
           </a:p>
-          <a:p>
-            <a:r>
-              <a:t>Source: 'Math Week 1'!A44:F44</a:t>
-            </a:r>
-          </a:p>
           <a:p/>
           <a:p>
             <a:r>
@@ -12134,11 +10669,6 @@
               <a:t>Materials/check: Exercise Book; tool above</a:t>
             </a:r>
           </a:p>
-          <a:p>
-            <a:r>
-              <a:t>Source: 'Math Week 1'!A45:F45</a:t>
-            </a:r>
-          </a:p>
           <a:p/>
           <a:p>
             <a:r>
@@ -12160,11 +10690,6 @@
               <a:t>Materials/check: Paper first; tool second</a:t>
             </a:r>
           </a:p>
-          <a:p>
-            <a:r>
-              <a:t>Source: 'Math Week 1'!A46:F46</a:t>
-            </a:r>
-          </a:p>
           <a:p/>
           <a:p>
             <a:r>
@@ -12186,11 +10711,6 @@
               <a:t>Materials/check: Teacher answers below</a:t>
             </a:r>
           </a:p>
-          <a:p>
-            <a:r>
-              <a:t>Source: 'Math Week 1'!A47:F47</a:t>
-            </a:r>
-          </a:p>
           <a:p/>
           <a:p>
             <a:r>
@@ -12212,11 +10732,6 @@
               <a:t>Materials/check: Notebook / error log</a:t>
             </a:r>
           </a:p>
-          <a:p>
-            <a:r>
-              <a:t>Source: 'Math Week 1'!A48:F48</a:t>
-            </a:r>
-          </a:p>
           <a:p/>
           <a:p>
             <a:r>
@@ -12237,17 +10752,12 @@
           <a:p/>
           <a:p>
             <a:r>
-              <a:t>Sources: 'Math Week 1'!A11:E11; 'Carpentry Schedule'!E5; 'Math Week 1'!A36</a:t>
-            </a:r>
-          </a:p>
-          <a:p>
-            <a:r>
-              <a:t>Navigation/resource slides support these scheduled steps and do not add instructional time.</a:t>
-            </a:r>
-          </a:p>
-          <a:p>
-            <a:r>
-              <a:t>SLIDE PLACEMENT: Practise, 11:10 AM–11:45 AM. All slides with this phase share these 35 minutes; do not restart the time allocation for each slide.</a:t>
+              <a:t>Keep activities within the allocated phase time.</a:t>
+            </a:r>
+          </a:p>
+          <a:p>
+            <a:r>
+              <a:t>PHASE TIMING: Practise, 11:10 AM–11:45 AM. All slides with this phase share these 35 minutes; do not restart the time allocation for each slide.</a:t>
             </a:r>
           </a:p>
           <a:p/>
@@ -12397,11 +10907,6 @@
               <a:t>Materials/check: Notebook; calculator</a:t>
             </a:r>
           </a:p>
-          <a:p>
-            <a:r>
-              <a:t>Source: 'Math Week 1'!A42:F42</a:t>
-            </a:r>
-          </a:p>
           <a:p/>
           <a:p>
             <a:r>
@@ -12423,11 +10928,6 @@
               <a:t>Materials/check: Identify support needs</a:t>
             </a:r>
           </a:p>
-          <a:p>
-            <a:r>
-              <a:t>Source: 'Math Week 1'!A43:F43</a:t>
-            </a:r>
-          </a:p>
           <a:p/>
           <a:p>
             <a:r>
@@ -12449,11 +10949,6 @@
               <a:t>Materials/check: Textbook; worked example</a:t>
             </a:r>
           </a:p>
-          <a:p>
-            <a:r>
-              <a:t>Source: 'Math Week 1'!A44:F44</a:t>
-            </a:r>
-          </a:p>
           <a:p/>
           <a:p>
             <a:r>
@@ -12475,11 +10970,6 @@
               <a:t>Materials/check: Exercise Book; tool above</a:t>
             </a:r>
           </a:p>
-          <a:p>
-            <a:r>
-              <a:t>Source: 'Math Week 1'!A45:F45</a:t>
-            </a:r>
-          </a:p>
           <a:p/>
           <a:p>
             <a:r>
@@ -12501,11 +10991,6 @@
               <a:t>Materials/check: Paper first; tool second</a:t>
             </a:r>
           </a:p>
-          <a:p>
-            <a:r>
-              <a:t>Source: 'Math Week 1'!A46:F46</a:t>
-            </a:r>
-          </a:p>
           <a:p/>
           <a:p>
             <a:r>
@@ -12527,11 +11012,6 @@
               <a:t>Materials/check: Teacher answers below</a:t>
             </a:r>
           </a:p>
-          <a:p>
-            <a:r>
-              <a:t>Source: 'Math Week 1'!A47:F47</a:t>
-            </a:r>
-          </a:p>
           <a:p/>
           <a:p>
             <a:r>
@@ -12553,11 +11033,6 @@
               <a:t>Materials/check: Notebook / error log</a:t>
             </a:r>
           </a:p>
-          <a:p>
-            <a:r>
-              <a:t>Source: 'Math Week 1'!A48:F48</a:t>
-            </a:r>
-          </a:p>
           <a:p/>
           <a:p>
             <a:r>
@@ -12578,17 +11053,12 @@
           <a:p/>
           <a:p>
             <a:r>
-              <a:t>Sources: 'Math Week 1'!A11:E11; 'Carpentry Schedule'!E5; 'Math Week 1'!A36</a:t>
-            </a:r>
-          </a:p>
-          <a:p>
-            <a:r>
-              <a:t>Navigation/resource slides support these scheduled steps and do not add instructional time.</a:t>
-            </a:r>
-          </a:p>
-          <a:p>
-            <a:r>
-              <a:t>SLIDE PLACEMENT: Practise, 11:10 AM–11:45 AM. All slides with this phase share these 35 minutes; do not restart the time allocation for each slide.</a:t>
+              <a:t>Keep activities within the allocated phase time.</a:t>
+            </a:r>
+          </a:p>
+          <a:p>
+            <a:r>
+              <a:t>PHASE TIMING: Practise, 11:10 AM–11:45 AM. All slides with this phase share these 35 minutes; do not restart the time allocation for each slide.</a:t>
             </a:r>
           </a:p>
           <a:p/>
@@ -12743,11 +11213,6 @@
               <a:t>Materials/check: Notebook; calculator</a:t>
             </a:r>
           </a:p>
-          <a:p>
-            <a:r>
-              <a:t>Source: 'Math Week 1'!A42:F42</a:t>
-            </a:r>
-          </a:p>
           <a:p/>
           <a:p>
             <a:r>
@@ -12769,11 +11234,6 @@
               <a:t>Materials/check: Identify support needs</a:t>
             </a:r>
           </a:p>
-          <a:p>
-            <a:r>
-              <a:t>Source: 'Math Week 1'!A43:F43</a:t>
-            </a:r>
-          </a:p>
           <a:p/>
           <a:p>
             <a:r>
@@ -12795,11 +11255,6 @@
               <a:t>Materials/check: Textbook; worked example</a:t>
             </a:r>
           </a:p>
-          <a:p>
-            <a:r>
-              <a:t>Source: 'Math Week 1'!A44:F44</a:t>
-            </a:r>
-          </a:p>
           <a:p/>
           <a:p>
             <a:r>
@@ -12821,11 +11276,6 @@
               <a:t>Materials/check: Exercise Book; tool above</a:t>
             </a:r>
           </a:p>
-          <a:p>
-            <a:r>
-              <a:t>Source: 'Math Week 1'!A45:F45</a:t>
-            </a:r>
-          </a:p>
           <a:p/>
           <a:p>
             <a:r>
@@ -12847,11 +11297,6 @@
               <a:t>Materials/check: Paper first; tool second</a:t>
             </a:r>
           </a:p>
-          <a:p>
-            <a:r>
-              <a:t>Source: 'Math Week 1'!A46:F46</a:t>
-            </a:r>
-          </a:p>
           <a:p/>
           <a:p>
             <a:r>
@@ -12873,11 +11318,6 @@
               <a:t>Materials/check: Teacher answers below</a:t>
             </a:r>
           </a:p>
-          <a:p>
-            <a:r>
-              <a:t>Source: 'Math Week 1'!A47:F47</a:t>
-            </a:r>
-          </a:p>
           <a:p/>
           <a:p>
             <a:r>
@@ -12899,11 +11339,6 @@
               <a:t>Materials/check: Notebook / error log</a:t>
             </a:r>
           </a:p>
-          <a:p>
-            <a:r>
-              <a:t>Source: 'Math Week 1'!A48:F48</a:t>
-            </a:r>
-          </a:p>
           <a:p/>
           <a:p>
             <a:r>
@@ -12924,17 +11359,12 @@
           <a:p/>
           <a:p>
             <a:r>
-              <a:t>Sources: 'Math Week 1'!A11:E11; 'Carpentry Schedule'!E5; 'Math Week 1'!A36</a:t>
-            </a:r>
-          </a:p>
-          <a:p>
-            <a:r>
-              <a:t>Navigation/resource slides support these scheduled steps and do not add instructional time.</a:t>
-            </a:r>
-          </a:p>
-          <a:p>
-            <a:r>
-              <a:t>SLIDE PLACEMENT: Practise, 11:10 AM–11:45 AM. All slides with this phase share these 35 minutes; do not restart the time allocation for each slide.</a:t>
+              <a:t>Keep activities within the allocated phase time.</a:t>
+            </a:r>
+          </a:p>
+          <a:p>
+            <a:r>
+              <a:t>PHASE TIMING: Practise, 11:10 AM–11:45 AM. All slides with this phase share these 35 minutes; do not restart the time allocation for each slide.</a:t>
             </a:r>
           </a:p>
           <a:p/>
@@ -13089,11 +11519,6 @@
               <a:t>Materials/check: Notebook; calculator</a:t>
             </a:r>
           </a:p>
-          <a:p>
-            <a:r>
-              <a:t>Source: 'Math Week 1'!A42:F42</a:t>
-            </a:r>
-          </a:p>
           <a:p/>
           <a:p>
             <a:r>
@@ -13115,11 +11540,6 @@
               <a:t>Materials/check: Identify support needs</a:t>
             </a:r>
           </a:p>
-          <a:p>
-            <a:r>
-              <a:t>Source: 'Math Week 1'!A43:F43</a:t>
-            </a:r>
-          </a:p>
           <a:p/>
           <a:p>
             <a:r>
@@ -13141,11 +11561,6 @@
               <a:t>Materials/check: Textbook; worked example</a:t>
             </a:r>
           </a:p>
-          <a:p>
-            <a:r>
-              <a:t>Source: 'Math Week 1'!A44:F44</a:t>
-            </a:r>
-          </a:p>
           <a:p/>
           <a:p>
             <a:r>
@@ -13167,11 +11582,6 @@
               <a:t>Materials/check: Exercise Book; tool above</a:t>
             </a:r>
           </a:p>
-          <a:p>
-            <a:r>
-              <a:t>Source: 'Math Week 1'!A45:F45</a:t>
-            </a:r>
-          </a:p>
           <a:p/>
           <a:p>
             <a:r>
@@ -13193,11 +11603,6 @@
               <a:t>Materials/check: Paper first; tool second</a:t>
             </a:r>
           </a:p>
-          <a:p>
-            <a:r>
-              <a:t>Source: 'Math Week 1'!A46:F46</a:t>
-            </a:r>
-          </a:p>
           <a:p/>
           <a:p>
             <a:r>
@@ -13219,11 +11624,6 @@
               <a:t>Materials/check: Teacher answers below</a:t>
             </a:r>
           </a:p>
-          <a:p>
-            <a:r>
-              <a:t>Source: 'Math Week 1'!A47:F47</a:t>
-            </a:r>
-          </a:p>
           <a:p/>
           <a:p>
             <a:r>
@@ -13245,11 +11645,6 @@
               <a:t>Materials/check: Notebook / error log</a:t>
             </a:r>
           </a:p>
-          <a:p>
-            <a:r>
-              <a:t>Source: 'Math Week 1'!A48:F48</a:t>
-            </a:r>
-          </a:p>
           <a:p/>
           <a:p>
             <a:r>
@@ -13270,17 +11665,12 @@
           <a:p/>
           <a:p>
             <a:r>
-              <a:t>Sources: 'Math Week 1'!A11:E11; 'Carpentry Schedule'!E5; 'Math Week 1'!A36</a:t>
-            </a:r>
-          </a:p>
-          <a:p>
-            <a:r>
-              <a:t>Navigation/resource slides support these scheduled steps and do not add instructional time.</a:t>
-            </a:r>
-          </a:p>
-          <a:p>
-            <a:r>
-              <a:t>SLIDE PLACEMENT: Check, 11:45 AM–11:55 AM. All slides with this phase share these 10 minutes; do not restart the time allocation for each slide.</a:t>
+              <a:t>Keep activities within the allocated phase time.</a:t>
+            </a:r>
+          </a:p>
+          <a:p>
+            <a:r>
+              <a:t>PHASE TIMING: Check, 11:45 AM–11:55 AM. All slides with this phase share these 10 minutes; do not restart the time allocation for each slide.</a:t>
             </a:r>
           </a:p>
         </p:txBody>
@@ -13409,11 +11799,6 @@
               <a:t>Materials/check: Notebook; calculator</a:t>
             </a:r>
           </a:p>
-          <a:p>
-            <a:r>
-              <a:t>Source: 'Math Week 1'!A42:F42</a:t>
-            </a:r>
-          </a:p>
           <a:p/>
           <a:p>
             <a:r>
@@ -13435,11 +11820,6 @@
               <a:t>Materials/check: Identify support needs</a:t>
             </a:r>
           </a:p>
-          <a:p>
-            <a:r>
-              <a:t>Source: 'Math Week 1'!A43:F43</a:t>
-            </a:r>
-          </a:p>
           <a:p/>
           <a:p>
             <a:r>
@@ -13461,11 +11841,6 @@
               <a:t>Materials/check: Textbook; worked example</a:t>
             </a:r>
           </a:p>
-          <a:p>
-            <a:r>
-              <a:t>Source: 'Math Week 1'!A44:F44</a:t>
-            </a:r>
-          </a:p>
           <a:p/>
           <a:p>
             <a:r>
@@ -13487,11 +11862,6 @@
               <a:t>Materials/check: Exercise Book; tool above</a:t>
             </a:r>
           </a:p>
-          <a:p>
-            <a:r>
-              <a:t>Source: 'Math Week 1'!A45:F45</a:t>
-            </a:r>
-          </a:p>
           <a:p/>
           <a:p>
             <a:r>
@@ -13513,11 +11883,6 @@
               <a:t>Materials/check: Paper first; tool second</a:t>
             </a:r>
           </a:p>
-          <a:p>
-            <a:r>
-              <a:t>Source: 'Math Week 1'!A46:F46</a:t>
-            </a:r>
-          </a:p>
           <a:p/>
           <a:p>
             <a:r>
@@ -13539,11 +11904,6 @@
               <a:t>Materials/check: Teacher answers below</a:t>
             </a:r>
           </a:p>
-          <a:p>
-            <a:r>
-              <a:t>Source: 'Math Week 1'!A47:F47</a:t>
-            </a:r>
-          </a:p>
           <a:p/>
           <a:p>
             <a:r>
@@ -13565,11 +11925,6 @@
               <a:t>Materials/check: Notebook / error log</a:t>
             </a:r>
           </a:p>
-          <a:p>
-            <a:r>
-              <a:t>Source: 'Math Week 1'!A48:F48</a:t>
-            </a:r>
-          </a:p>
           <a:p/>
           <a:p>
             <a:r>
@@ -13590,17 +11945,12 @@
           <a:p/>
           <a:p>
             <a:r>
-              <a:t>Sources: 'Math Week 1'!A11:E11; 'Carpentry Schedule'!E5; 'Math Week 1'!A36</a:t>
-            </a:r>
-          </a:p>
-          <a:p>
-            <a:r>
-              <a:t>Navigation/resource slides support these scheduled steps and do not add instructional time.</a:t>
-            </a:r>
-          </a:p>
-          <a:p>
-            <a:r>
-              <a:t>SLIDE PLACEMENT: Check, 11:45 AM–11:55 AM. All slides with this phase share these 10 minutes; do not restart the time allocation for each slide.</a:t>
+              <a:t>Keep activities within the allocated phase time.</a:t>
+            </a:r>
+          </a:p>
+          <a:p>
+            <a:r>
+              <a:t>PHASE TIMING: Check, 11:45 AM–11:55 AM. All slides with this phase share these 10 minutes; do not restart the time allocation for each slide.</a:t>
             </a:r>
           </a:p>
           <a:p/>
@@ -13755,11 +12105,6 @@
               <a:t>Materials/check: Notebook; calculator</a:t>
             </a:r>
           </a:p>
-          <a:p>
-            <a:r>
-              <a:t>Source: 'Math Week 1'!A42:F42</a:t>
-            </a:r>
-          </a:p>
           <a:p/>
           <a:p>
             <a:r>
@@ -13781,11 +12126,6 @@
               <a:t>Materials/check: Identify support needs</a:t>
             </a:r>
           </a:p>
-          <a:p>
-            <a:r>
-              <a:t>Source: 'Math Week 1'!A43:F43</a:t>
-            </a:r>
-          </a:p>
           <a:p/>
           <a:p>
             <a:r>
@@ -13807,11 +12147,6 @@
               <a:t>Materials/check: Textbook; worked example</a:t>
             </a:r>
           </a:p>
-          <a:p>
-            <a:r>
-              <a:t>Source: 'Math Week 1'!A44:F44</a:t>
-            </a:r>
-          </a:p>
           <a:p/>
           <a:p>
             <a:r>
@@ -13833,11 +12168,6 @@
               <a:t>Materials/check: Exercise Book; tool above</a:t>
             </a:r>
           </a:p>
-          <a:p>
-            <a:r>
-              <a:t>Source: 'Math Week 1'!A45:F45</a:t>
-            </a:r>
-          </a:p>
           <a:p/>
           <a:p>
             <a:r>
@@ -13859,11 +12189,6 @@
               <a:t>Materials/check: Paper first; tool second</a:t>
             </a:r>
           </a:p>
-          <a:p>
-            <a:r>
-              <a:t>Source: 'Math Week 1'!A46:F46</a:t>
-            </a:r>
-          </a:p>
           <a:p/>
           <a:p>
             <a:r>
@@ -13885,11 +12210,6 @@
               <a:t>Materials/check: Teacher answers below</a:t>
             </a:r>
           </a:p>
-          <a:p>
-            <a:r>
-              <a:t>Source: 'Math Week 1'!A47:F47</a:t>
-            </a:r>
-          </a:p>
           <a:p/>
           <a:p>
             <a:r>
@@ -13911,11 +12231,6 @@
               <a:t>Materials/check: Notebook / error log</a:t>
             </a:r>
           </a:p>
-          <a:p>
-            <a:r>
-              <a:t>Source: 'Math Week 1'!A48:F48</a:t>
-            </a:r>
-          </a:p>
           <a:p/>
           <a:p>
             <a:r>
@@ -13936,17 +12251,12 @@
           <a:p/>
           <a:p>
             <a:r>
-              <a:t>Sources: 'Math Week 1'!A11:E11; 'Carpentry Schedule'!E5; 'Math Week 1'!A36</a:t>
-            </a:r>
-          </a:p>
-          <a:p>
-            <a:r>
-              <a:t>Navigation/resource slides support these scheduled steps and do not add instructional time.</a:t>
-            </a:r>
-          </a:p>
-          <a:p>
-            <a:r>
-              <a:t>SLIDE PLACEMENT: Check, 11:45 AM–11:55 AM. All slides with this phase share these 10 minutes; do not restart the time allocation for each slide.</a:t>
+              <a:t>Keep activities within the allocated phase time.</a:t>
+            </a:r>
+          </a:p>
+          <a:p>
+            <a:r>
+              <a:t>PHASE TIMING: Check, 11:45 AM–11:55 AM. All slides with this phase share these 10 minutes; do not restart the time allocation for each slide.</a:t>
             </a:r>
           </a:p>
           <a:p/>
@@ -14101,11 +12411,6 @@
               <a:t>Materials/check: Notebook; calculator</a:t>
             </a:r>
           </a:p>
-          <a:p>
-            <a:r>
-              <a:t>Source: 'Math Week 1'!A42:F42</a:t>
-            </a:r>
-          </a:p>
           <a:p/>
           <a:p>
             <a:r>
@@ -14127,11 +12432,6 @@
               <a:t>Materials/check: Identify support needs</a:t>
             </a:r>
           </a:p>
-          <a:p>
-            <a:r>
-              <a:t>Source: 'Math Week 1'!A43:F43</a:t>
-            </a:r>
-          </a:p>
           <a:p/>
           <a:p>
             <a:r>
@@ -14153,11 +12453,6 @@
               <a:t>Materials/check: Textbook; worked example</a:t>
             </a:r>
           </a:p>
-          <a:p>
-            <a:r>
-              <a:t>Source: 'Math Week 1'!A44:F44</a:t>
-            </a:r>
-          </a:p>
           <a:p/>
           <a:p>
             <a:r>
@@ -14179,11 +12474,6 @@
               <a:t>Materials/check: Exercise Book; tool above</a:t>
             </a:r>
           </a:p>
-          <a:p>
-            <a:r>
-              <a:t>Source: 'Math Week 1'!A45:F45</a:t>
-            </a:r>
-          </a:p>
           <a:p/>
           <a:p>
             <a:r>
@@ -14205,11 +12495,6 @@
               <a:t>Materials/check: Paper first; tool second</a:t>
             </a:r>
           </a:p>
-          <a:p>
-            <a:r>
-              <a:t>Source: 'Math Week 1'!A46:F46</a:t>
-            </a:r>
-          </a:p>
           <a:p/>
           <a:p>
             <a:r>
@@ -14231,11 +12516,6 @@
               <a:t>Materials/check: Teacher answers below</a:t>
             </a:r>
           </a:p>
-          <a:p>
-            <a:r>
-              <a:t>Source: 'Math Week 1'!A47:F47</a:t>
-            </a:r>
-          </a:p>
           <a:p/>
           <a:p>
             <a:r>
@@ -14257,11 +12537,6 @@
               <a:t>Materials/check: Notebook / error log</a:t>
             </a:r>
           </a:p>
-          <a:p>
-            <a:r>
-              <a:t>Source: 'Math Week 1'!A48:F48</a:t>
-            </a:r>
-          </a:p>
           <a:p/>
           <a:p>
             <a:r>
@@ -14282,17 +12557,12 @@
           <a:p/>
           <a:p>
             <a:r>
-              <a:t>Sources: 'Math Week 1'!A11:E11; 'Carpentry Schedule'!E5; 'Math Week 1'!A36</a:t>
-            </a:r>
-          </a:p>
-          <a:p>
-            <a:r>
-              <a:t>Navigation/resource slides support these scheduled steps and do not add instructional time.</a:t>
-            </a:r>
-          </a:p>
-          <a:p>
-            <a:r>
-              <a:t>SLIDE PLACEMENT: Wrap up, 11:55 AM–12:00 PM. All slides with this phase share these 5 minutes; do not restart the time allocation for each slide.</a:t>
+              <a:t>Keep activities within the allocated phase time.</a:t>
+            </a:r>
+          </a:p>
+          <a:p>
+            <a:r>
+              <a:t>PHASE TIMING: Wrap up, 11:55 AM–12:00 PM. All slides with this phase share these 5 minutes; do not restart the time allocation for each slide.</a:t>
             </a:r>
           </a:p>
           <a:p/>
@@ -14427,11 +12697,6 @@
               <a:t>Materials/check: Notebook; calculator</a:t>
             </a:r>
           </a:p>
-          <a:p>
-            <a:r>
-              <a:t>Source: 'Math Week 1'!A25:F25</a:t>
-            </a:r>
-          </a:p>
           <a:p/>
           <a:p>
             <a:r>
@@ -14453,11 +12718,6 @@
               <a:t>Materials/check: Identify support needs</a:t>
             </a:r>
           </a:p>
-          <a:p>
-            <a:r>
-              <a:t>Source: 'Math Week 1'!A26:F26</a:t>
-            </a:r>
-          </a:p>
           <a:p/>
           <a:p>
             <a:r>
@@ -14479,11 +12739,6 @@
               <a:t>Materials/check: Textbook; worked example</a:t>
             </a:r>
           </a:p>
-          <a:p>
-            <a:r>
-              <a:t>Source: 'Math Week 1'!A27:F27</a:t>
-            </a:r>
-          </a:p>
           <a:p/>
           <a:p>
             <a:r>
@@ -14505,11 +12760,6 @@
               <a:t>Materials/check: Exercise Book; tool above</a:t>
             </a:r>
           </a:p>
-          <a:p>
-            <a:r>
-              <a:t>Source: 'Math Week 1'!A28:F28</a:t>
-            </a:r>
-          </a:p>
           <a:p/>
           <a:p>
             <a:r>
@@ -14531,11 +12781,6 @@
               <a:t>Materials/check: Paper first; tool second</a:t>
             </a:r>
           </a:p>
-          <a:p>
-            <a:r>
-              <a:t>Source: 'Math Week 1'!A29:F29</a:t>
-            </a:r>
-          </a:p>
           <a:p/>
           <a:p>
             <a:r>
@@ -14557,11 +12802,6 @@
               <a:t>Materials/check: Teacher answers below</a:t>
             </a:r>
           </a:p>
-          <a:p>
-            <a:r>
-              <a:t>Source: 'Math Week 1'!A30:F30</a:t>
-            </a:r>
-          </a:p>
           <a:p/>
           <a:p>
             <a:r>
@@ -14583,11 +12823,6 @@
               <a:t>Materials/check: Notebook / error log</a:t>
             </a:r>
           </a:p>
-          <a:p>
-            <a:r>
-              <a:t>Source: 'Math Week 1'!A31:F31</a:t>
-            </a:r>
-          </a:p>
           <a:p/>
           <a:p>
             <a:r>
@@ -14608,17 +12843,12 @@
           <a:p/>
           <a:p>
             <a:r>
-              <a:t>Sources: 'Math Week 1'!A10:E10; 'Carpentry Schedule'!E3; 'Math Week 1'!A19</a:t>
-            </a:r>
-          </a:p>
-          <a:p>
-            <a:r>
-              <a:t>Navigation/resource slides support these scheduled steps and do not add instructional time.</a:t>
-            </a:r>
-          </a:p>
-          <a:p>
-            <a:r>
-              <a:t>Worked teaching example retained from original slide 4. Use within the scheduled Teach block.</a:t>
+              <a:t>Keep activities within the allocated phase time.</a:t>
+            </a:r>
+          </a:p>
+          <a:p>
+            <a:r>
+              <a:t>Use this worked example within the scheduled Teach block.</a:t>
             </a:r>
           </a:p>
         </p:txBody>
@@ -14763,11 +12993,6 @@
               <a:t>Materials/check: Notebook; calculator</a:t>
             </a:r>
           </a:p>
-          <a:p>
-            <a:r>
-              <a:t>Source: 'Math Week 1'!A42:F42</a:t>
-            </a:r>
-          </a:p>
           <a:p/>
           <a:p>
             <a:r>
@@ -14789,11 +13014,6 @@
               <a:t>Materials/check: Identify support needs</a:t>
             </a:r>
           </a:p>
-          <a:p>
-            <a:r>
-              <a:t>Source: 'Math Week 1'!A43:F43</a:t>
-            </a:r>
-          </a:p>
           <a:p/>
           <a:p>
             <a:r>
@@ -14815,11 +13035,6 @@
               <a:t>Materials/check: Textbook; worked example</a:t>
             </a:r>
           </a:p>
-          <a:p>
-            <a:r>
-              <a:t>Source: 'Math Week 1'!A44:F44</a:t>
-            </a:r>
-          </a:p>
           <a:p/>
           <a:p>
             <a:r>
@@ -14841,11 +13056,6 @@
               <a:t>Materials/check: Exercise Book; tool above</a:t>
             </a:r>
           </a:p>
-          <a:p>
-            <a:r>
-              <a:t>Source: 'Math Week 1'!A45:F45</a:t>
-            </a:r>
-          </a:p>
           <a:p/>
           <a:p>
             <a:r>
@@ -14867,11 +13077,6 @@
               <a:t>Materials/check: Paper first; tool second</a:t>
             </a:r>
           </a:p>
-          <a:p>
-            <a:r>
-              <a:t>Source: 'Math Week 1'!A46:F46</a:t>
-            </a:r>
-          </a:p>
           <a:p/>
           <a:p>
             <a:r>
@@ -14893,11 +13098,6 @@
               <a:t>Materials/check: Teacher answers below</a:t>
             </a:r>
           </a:p>
-          <a:p>
-            <a:r>
-              <a:t>Source: 'Math Week 1'!A47:F47</a:t>
-            </a:r>
-          </a:p>
           <a:p/>
           <a:p>
             <a:r>
@@ -14919,11 +13119,6 @@
               <a:t>Materials/check: Notebook / error log</a:t>
             </a:r>
           </a:p>
-          <a:p>
-            <a:r>
-              <a:t>Source: 'Math Week 1'!A48:F48</a:t>
-            </a:r>
-          </a:p>
           <a:p/>
           <a:p>
             <a:r>
@@ -14944,17 +13139,12 @@
           <a:p/>
           <a:p>
             <a:r>
-              <a:t>Sources: 'Math Week 1'!A11:E11; 'Carpentry Schedule'!E5; 'Math Week 1'!A36</a:t>
-            </a:r>
-          </a:p>
-          <a:p>
-            <a:r>
-              <a:t>Navigation/resource slides support these scheduled steps and do not add instructional time.</a:t>
-            </a:r>
-          </a:p>
-          <a:p>
-            <a:r>
-              <a:t>Worked teaching example retained from original slide 7. Use within the scheduled Teach block.</a:t>
+              <a:t>Keep activities within the allocated phase time.</a:t>
+            </a:r>
+          </a:p>
+          <a:p>
+            <a:r>
+              <a:t>Use this worked example within the scheduled Teach block.</a:t>
             </a:r>
           </a:p>
         </p:txBody>

</xml_diff>